<commit_message>
[PC] Diaporama PLEIADE v2 : revue visuelle DESIGNER (avis 107), corrections et PDF de secours
Co-Authored-By: Claude Opus 5.5 <noreply@anthropic.com>
</commit_message>
<xml_diff>
--- a/PLEIADE/PRESENTATION/PLEIADE_presentation_v2.pptx
+++ b/PLEIADE/PRESENTATION/PLEIADE_presentation_v2.pptx
@@ -121,7 +121,7 @@
 <c:chartSpace xmlns:c="http://schemas.openxmlformats.org/drawingml/2006/chart" xmlns:a="http://schemas.openxmlformats.org/drawingml/2006/main" xmlns:r="http://schemas.openxmlformats.org/officeDocument/2006/relationships">
   <c:date1904 val="0"/>
   <c:chart>
-    <c:autoTitleDeleted val="0"/>
+    <c:autoTitleDeleted val="1"/>
     <c:plotArea>
       <c:lineChart>
         <c:grouping val="standard"/>
@@ -225,7 +225,7 @@
         <c:axPos val="b"/>
         <c:majorTickMark val="out"/>
         <c:minorTickMark val="none"/>
-        <c:tickLblPos val="nextTo"/>
+        <c:tickLblPos val="low"/>
         <c:spPr>
           <a:ln>
             <a:solidFill>
@@ -238,7 +238,7 @@
           <a:lstStyle/>
           <a:p>
             <a:pPr>
-              <a:defRPr sz="1600"/>
+              <a:defRPr sz="1800"/>
             </a:pPr>
           </a:p>
         </c:txPr>
@@ -266,6 +266,7 @@
             </a:ln>
           </c:spPr>
         </c:majorGridlines>
+        <c:numFmt formatCode="+0;−0;0" sourceLinked="0"/>
         <c:majorTickMark val="out"/>
         <c:minorTickMark val="none"/>
         <c:tickLblPos val="nextTo"/>
@@ -279,7 +280,7 @@
           <a:lstStyle/>
           <a:p>
             <a:pPr>
-              <a:defRPr sz="1600"/>
+              <a:defRPr sz="1800"/>
             </a:pPr>
           </a:p>
         </c:txPr>
@@ -4809,7 +4810,7 @@
                 </a:solidFill>
                 <a:latin typeface="Arial"/>
               </a:rPr>
-              <a:t>L'espace informationnel d'entraînement du CECPC</a:t>
+              <a:t>L’espace informationnel d’entraînement du CECPC</a:t>
             </a:r>
           </a:p>
         </p:txBody>
@@ -4847,11 +4848,11 @@
             <a:r>
               <a:rPr sz="2000" b="0">
                 <a:solidFill>
-                  <a:srgbClr val="9AA0B4"/>
-                </a:solidFill>
-                <a:latin typeface="Arial"/>
-              </a:rPr>
-              <a:t>D'ORION 26 à DELATTRE 26 · six mois d'avancées</a:t>
+                  <a:srgbClr val="C3C8D8"/>
+                </a:solidFill>
+                <a:latin typeface="Arial"/>
+              </a:rPr>
+              <a:t>D’ORION 26 à DELATTRE 26 · six mois d’avancées</a:t>
             </a:r>
           </a:p>
         </p:txBody>
@@ -4864,7 +4865,7 @@
         </p:nvSpPr>
         <p:spPr>
           <a:xfrm>
-            <a:off x="609600" y="6350000"/>
+            <a:off x="609600" y="6413500"/>
             <a:ext cx="10972800" cy="254000"/>
           </a:xfrm>
           <a:prstGeom prst="rect">
@@ -4893,7 +4894,7 @@
                 </a:solidFill>
                 <a:latin typeface="Arial"/>
               </a:rPr>
-              <a:t>Exercice · non classifié · pays, personnages, médias et villes cités : fictifs</a:t>
+              <a:t>Exercice · non classifié · pays, personnages, médias et villes cités : fictifs</a:t>
             </a:r>
           </a:p>
         </p:txBody>
@@ -4961,7 +4962,7 @@
                 </a:solidFill>
                 <a:latin typeface="Arial"/>
               </a:rPr>
-              <a:t>Fermé, local, réparti : rien ne sort de la salle</a:t>
+              <a:t>Fermé, local, réparti : rien ne sort de la salle</a:t>
             </a:r>
           </a:p>
         </p:txBody>
@@ -5173,7 +5174,7 @@
                 </a:solidFill>
                 <a:latin typeface="Arial"/>
               </a:rPr>
-              <a:t>les zones d'exercice</a:t>
+              <a:t>les zones d’exercice</a:t>
             </a:r>
           </a:p>
         </p:txBody>
@@ -5280,7 +5281,7 @@
                 </a:solidFill>
                 <a:latin typeface="Arial"/>
               </a:rPr>
-              <a:t>PC et Mac de l'équipe</a:t>
+              <a:t>PC et Mac</a:t>
             </a:r>
           </a:p>
         </p:txBody>
@@ -5293,8 +5294,8 @@
         </p:nvSpPr>
         <p:spPr>
           <a:xfrm>
-            <a:off x="3835400" y="2844800"/>
-            <a:ext cx="558800" cy="279400"/>
+            <a:off x="3975100" y="2857500"/>
+            <a:ext cx="279400" cy="254000"/>
           </a:xfrm>
           <a:prstGeom prst="rightArrow">
             <a:avLst/>
@@ -5337,8 +5338,8 @@
         </p:nvSpPr>
         <p:spPr>
           <a:xfrm>
-            <a:off x="3657600" y="3225800"/>
-            <a:ext cx="914400" cy="254000"/>
+            <a:off x="3657600" y="3200400"/>
+            <a:ext cx="914400" cy="279400"/>
           </a:xfrm>
           <a:prstGeom prst="rect">
             <a:avLst/>
@@ -5360,7 +5361,7 @@
               </a:spcAft>
             </a:pPr>
             <a:r>
-              <a:rPr sz="1400" b="1">
+              <a:rPr sz="1800" b="1">
                 <a:solidFill>
                   <a:srgbClr val="3B3E46"/>
                 </a:solidFill>
@@ -5379,8 +5380,8 @@
         </p:nvSpPr>
         <p:spPr>
           <a:xfrm>
-            <a:off x="7797800" y="2844800"/>
-            <a:ext cx="558800" cy="279400"/>
+            <a:off x="7937500" y="2857500"/>
+            <a:ext cx="279400" cy="254000"/>
           </a:xfrm>
           <a:prstGeom prst="rightArrow">
             <a:avLst/>
@@ -5423,8 +5424,8 @@
         </p:nvSpPr>
         <p:spPr>
           <a:xfrm>
-            <a:off x="7620000" y="3225800"/>
-            <a:ext cx="914400" cy="254000"/>
+            <a:off x="7620000" y="3200400"/>
+            <a:ext cx="914400" cy="279400"/>
           </a:xfrm>
           <a:prstGeom prst="rect">
             <a:avLst/>
@@ -5446,7 +5447,7 @@
               </a:spcAft>
             </a:pPr>
             <a:r>
-              <a:rPr sz="1400" b="1">
+              <a:rPr sz="1800" b="1">
                 <a:solidFill>
                   <a:srgbClr val="3B3E46"/>
                 </a:solidFill>
@@ -5538,7 +5539,7 @@
                 </a:solidFill>
                 <a:latin typeface="Arial"/>
               </a:rPr>
-              <a:t>IA locale, sous licence libre (Gemma 4) : aucun service en ligne</a:t>
+              <a:t>IA locale, licence libre : aucun service en ligne</a:t>
             </a:r>
           </a:p>
         </p:txBody>
@@ -5624,7 +5625,7 @@
                 </a:solidFill>
                 <a:latin typeface="Arial"/>
               </a:rPr>
-              <a:t>Une machine s'arrête : ses avatars sont repris par une autre</a:t>
+              <a:t>Une machine s’arrête : une autre reprend ses avatars</a:t>
             </a:r>
           </a:p>
         </p:txBody>
@@ -5710,7 +5711,7 @@
                 </a:solidFill>
                 <a:latin typeface="Arial"/>
               </a:rPr>
-              <a:t>Être sur le VPN ne donne aucun droit : chaque application vérifie les siens</a:t>
+              <a:t>Le VPN ne donne aucun droit</a:t>
             </a:r>
           </a:p>
         </p:txBody>
@@ -5723,7 +5724,7 @@
         </p:nvSpPr>
         <p:spPr>
           <a:xfrm>
-            <a:off x="609600" y="6477000"/>
+            <a:off x="609600" y="6413500"/>
             <a:ext cx="7620000" cy="203200"/>
           </a:xfrm>
           <a:prstGeom prst="rect">
@@ -5765,7 +5766,7 @@
         </p:nvSpPr>
         <p:spPr>
           <a:xfrm>
-            <a:off x="10312400" y="6477000"/>
+            <a:off x="10312400" y="6413500"/>
             <a:ext cx="1270000" cy="203200"/>
           </a:xfrm>
           <a:prstGeom prst="rect">
@@ -5917,7 +5918,7 @@
         </p:nvSpPr>
         <p:spPr>
           <a:xfrm>
-            <a:off x="3175000" y="1955800"/>
+            <a:off x="3175000" y="1993900"/>
             <a:ext cx="4826000" cy="635000"/>
           </a:xfrm>
           <a:prstGeom prst="rect">
@@ -6001,7 +6002,7 @@
         </p:nvSpPr>
         <p:spPr>
           <a:xfrm>
-            <a:off x="3175000" y="2692400"/>
+            <a:off x="3175000" y="2730500"/>
             <a:ext cx="4826000" cy="635000"/>
           </a:xfrm>
           <a:prstGeom prst="rect">
@@ -6085,7 +6086,7 @@
         </p:nvSpPr>
         <p:spPr>
           <a:xfrm>
-            <a:off x="3175000" y="3429000"/>
+            <a:off x="3175000" y="3467100"/>
             <a:ext cx="4826000" cy="635000"/>
           </a:xfrm>
           <a:prstGeom prst="rect">
@@ -6114,7 +6115,7 @@
                 </a:solidFill>
                 <a:latin typeface="Arial"/>
               </a:rPr>
-              <a:t>l'espace avec une population simulée</a:t>
+              <a:t>l’espace avec une population simulée</a:t>
             </a:r>
           </a:p>
         </p:txBody>
@@ -6169,7 +6170,7 @@
         </p:nvSpPr>
         <p:spPr>
           <a:xfrm>
-            <a:off x="3175000" y="4165600"/>
+            <a:off x="3175000" y="4203700"/>
             <a:ext cx="4826000" cy="635000"/>
           </a:xfrm>
           <a:prstGeom prst="rect">
@@ -6198,7 +6199,7 @@
                 </a:solidFill>
                 <a:latin typeface="Arial"/>
               </a:rPr>
-              <a:t>l'effet des joueurs sur l'opinion</a:t>
+              <a:t>l’effet des joueurs sur l’opinion</a:t>
             </a:r>
           </a:p>
         </p:txBody>
@@ -6212,7 +6213,7 @@
         <p:spPr>
           <a:xfrm>
             <a:off x="8382000" y="1905000"/>
-            <a:ext cx="3200400" cy="3302000"/>
+            <a:ext cx="3200400" cy="2540000"/>
           </a:xfrm>
           <a:prstGeom prst="rect">
             <a:avLst/>
@@ -6256,7 +6257,7 @@
         <p:spPr>
           <a:xfrm>
             <a:off x="8636000" y="2108200"/>
-            <a:ext cx="2794000" cy="3048000"/>
+            <a:ext cx="2794000" cy="2286000"/>
           </a:xfrm>
           <a:prstGeom prst="rect">
             <a:avLst/>
@@ -6303,7 +6304,7 @@
                 </a:solidFill>
                 <a:latin typeface="Arial"/>
               </a:rPr>
-              <a:t>◐ en essai : rédacteur, émotions</a:t>
+              <a:t>◐ en essai : rédacteur, émotions</a:t>
             </a:r>
           </a:p>
           <a:p>
@@ -6322,7 +6323,7 @@
                 </a:solidFill>
                 <a:latin typeface="Arial"/>
               </a:rPr>
-              <a:t>○ à l'étude : lecture des images</a:t>
+              <a:t>○ à l’étude : lecture d’images</a:t>
             </a:r>
           </a:p>
           <a:p>
@@ -6341,7 +6342,7 @@
                 </a:solidFill>
                 <a:latin typeface="Arial"/>
               </a:rPr>
-              <a:t>○ ensuite : plus d'avatars, plus de machines</a:t>
+              <a:t>→ ensuite : plus d’avatars</a:t>
             </a:r>
           </a:p>
         </p:txBody>
@@ -6662,7 +6663,7 @@
         </p:nvSpPr>
         <p:spPr>
           <a:xfrm>
-            <a:off x="609600" y="6477000"/>
+            <a:off x="609600" y="6413500"/>
             <a:ext cx="7620000" cy="203200"/>
           </a:xfrm>
           <a:prstGeom prst="rect">
@@ -6704,7 +6705,7 @@
         </p:nvSpPr>
         <p:spPr>
           <a:xfrm>
-            <a:off x="10312400" y="6477000"/>
+            <a:off x="10312400" y="6413500"/>
             <a:ext cx="1270000" cy="203200"/>
           </a:xfrm>
           <a:prstGeom prst="rect">
@@ -6801,7 +6802,26 @@
                 </a:solidFill>
                 <a:latin typeface="Arial"/>
               </a:rPr>
-              <a:t>La lutte informationnelle se joue en ligne : PLÉIADE la reproduit en vase clos</a:t>
+              <a:t>La lutte informationnelle se joue en ligne :</a:t>
+            </a:r>
+          </a:p>
+          <a:p>
+            <a:pPr algn="l">
+              <a:lnSpc>
+                <a:spcPct val="105000"/>
+              </a:lnSpc>
+              <a:spcAft>
+                <a:spcPts val="0"/>
+              </a:spcAft>
+            </a:pPr>
+            <a:r>
+              <a:rPr sz="3200" b="1">
+                <a:solidFill>
+                  <a:srgbClr val="14140F"/>
+                </a:solidFill>
+                <a:latin typeface="Arial"/>
+              </a:rPr>
+              <a:t>PLÉIADE la reproduit en vase clos</a:t>
             </a:r>
           </a:p>
         </p:txBody>
@@ -6814,8 +6834,8 @@
         </p:nvSpPr>
         <p:spPr>
           <a:xfrm>
-            <a:off x="609600" y="1930400"/>
-            <a:ext cx="5334000" cy="3810000"/>
+            <a:off x="914400" y="1930400"/>
+            <a:ext cx="5029200" cy="3810000"/>
           </a:xfrm>
           <a:prstGeom prst="rect">
             <a:avLst/>
@@ -6858,7 +6878,7 @@
         </p:nvSpPr>
         <p:spPr>
           <a:xfrm>
-            <a:off x="812800" y="2082800"/>
+            <a:off x="1219200" y="2082800"/>
             <a:ext cx="3810000" cy="254000"/>
           </a:xfrm>
           <a:prstGeom prst="rect">
@@ -6900,8 +6920,8 @@
         </p:nvSpPr>
         <p:spPr>
           <a:xfrm>
-            <a:off x="914400" y="2540000"/>
-            <a:ext cx="4724400" cy="762000"/>
+            <a:off x="1219200" y="2540000"/>
+            <a:ext cx="4419600" cy="762000"/>
           </a:xfrm>
           <a:prstGeom prst="rect">
             <a:avLst/>
@@ -6944,8 +6964,8 @@
         </p:nvSpPr>
         <p:spPr>
           <a:xfrm>
-            <a:off x="1168400" y="2540000"/>
-            <a:ext cx="4318000" cy="762000"/>
+            <a:off x="1473200" y="2540000"/>
+            <a:ext cx="4013200" cy="762000"/>
           </a:xfrm>
           <a:prstGeom prst="rect">
             <a:avLst/>
@@ -6986,8 +7006,8 @@
         </p:nvSpPr>
         <p:spPr>
           <a:xfrm>
-            <a:off x="914400" y="3530600"/>
-            <a:ext cx="4724400" cy="762000"/>
+            <a:off x="1219200" y="3530600"/>
+            <a:ext cx="4419600" cy="762000"/>
           </a:xfrm>
           <a:prstGeom prst="rect">
             <a:avLst/>
@@ -7030,8 +7050,8 @@
         </p:nvSpPr>
         <p:spPr>
           <a:xfrm>
-            <a:off x="1168400" y="3530600"/>
-            <a:ext cx="4318000" cy="762000"/>
+            <a:off x="1473200" y="3530600"/>
+            <a:ext cx="4013200" cy="762000"/>
           </a:xfrm>
           <a:prstGeom prst="rect">
             <a:avLst/>
@@ -7072,8 +7092,8 @@
         </p:nvSpPr>
         <p:spPr>
           <a:xfrm>
-            <a:off x="914400" y="4521200"/>
-            <a:ext cx="4724400" cy="762000"/>
+            <a:off x="1219200" y="4521200"/>
+            <a:ext cx="4419600" cy="762000"/>
           </a:xfrm>
           <a:prstGeom prst="rect">
             <a:avLst/>
@@ -7116,8 +7136,8 @@
         </p:nvSpPr>
         <p:spPr>
           <a:xfrm>
-            <a:off x="1168400" y="4521200"/>
-            <a:ext cx="4318000" cy="762000"/>
+            <a:off x="1473200" y="4521200"/>
+            <a:ext cx="4013200" cy="762000"/>
           </a:xfrm>
           <a:prstGeom prst="rect">
             <a:avLst/>
@@ -7158,8 +7178,8 @@
         </p:nvSpPr>
         <p:spPr>
           <a:xfrm>
-            <a:off x="381000" y="3657600"/>
-            <a:ext cx="457200" cy="457200"/>
+            <a:off x="609600" y="3657600"/>
+            <a:ext cx="609600" cy="457200"/>
           </a:xfrm>
           <a:prstGeom prst="rect">
             <a:avLst/>
@@ -7204,8 +7224,8 @@
         </p:nvSpPr>
         <p:spPr>
           <a:xfrm>
-            <a:off x="381000" y="3657600"/>
-            <a:ext cx="457200" cy="457200"/>
+            <a:off x="609600" y="3657600"/>
+            <a:ext cx="609600" cy="457200"/>
           </a:xfrm>
           <a:prstGeom prst="rect">
             <a:avLst/>
@@ -7227,7 +7247,7 @@
               </a:spcAft>
             </a:pPr>
             <a:r>
-              <a:rPr sz="1200" b="1">
+              <a:rPr sz="1800" b="1">
                 <a:solidFill>
                   <a:srgbClr val="1C1E21"/>
                 </a:solidFill>
@@ -7332,7 +7352,7 @@
               </a:spcAft>
             </a:pPr>
             <a:r>
-              <a:rPr sz="1800" b="0">
+              <a:rPr sz="2000" b="0">
                 <a:solidFill>
                   <a:srgbClr val="3B3E46"/>
                 </a:solidFill>
@@ -7437,7 +7457,7 @@
               </a:spcAft>
             </a:pPr>
             <a:r>
-              <a:rPr sz="1800" b="0">
+              <a:rPr sz="2000" b="0">
                 <a:solidFill>
                   <a:srgbClr val="3B3E46"/>
                 </a:solidFill>
@@ -7542,7 +7562,7 @@
               </a:spcAft>
             </a:pPr>
             <a:r>
-              <a:rPr sz="1800" b="0">
+              <a:rPr sz="2000" b="0">
                 <a:solidFill>
                   <a:srgbClr val="3B3E46"/>
                 </a:solidFill>
@@ -7647,13 +7667,13 @@
               </a:spcAft>
             </a:pPr>
             <a:r>
-              <a:rPr sz="1800" b="0">
+              <a:rPr sz="2000" b="0">
                 <a:solidFill>
                   <a:srgbClr val="3B3E46"/>
                 </a:solidFill>
                 <a:latin typeface="Arial"/>
               </a:rPr>
-              <a:t>tout se réutilise d'un exercice à l'autre</a:t>
+              <a:t>tout se réutilise d’un exercice à l’autre</a:t>
             </a:r>
           </a:p>
         </p:txBody>
@@ -7666,7 +7686,7 @@
         </p:nvSpPr>
         <p:spPr>
           <a:xfrm>
-            <a:off x="609600" y="6477000"/>
+            <a:off x="609600" y="6413500"/>
             <a:ext cx="7620000" cy="203200"/>
           </a:xfrm>
           <a:prstGeom prst="rect">
@@ -7708,7 +7728,7 @@
         </p:nvSpPr>
         <p:spPr>
           <a:xfrm>
-            <a:off x="10312400" y="6477000"/>
+            <a:off x="10312400" y="6413500"/>
             <a:ext cx="1270000" cy="203200"/>
           </a:xfrm>
           <a:prstGeom prst="rect">
@@ -7805,7 +7825,7 @@
                 </a:solidFill>
                 <a:latin typeface="Arial"/>
               </a:rPr>
-              <a:t>Six mois, quatre exercices : chaque manque a produit un outil</a:t>
+              <a:t>Six mois, quatre exercices : chaque manque a produit un outil</a:t>
             </a:r>
           </a:p>
         </p:txBody>
@@ -7819,7 +7839,7 @@
         <p:spPr>
           <a:xfrm>
             <a:off x="914400" y="3810000"/>
-            <a:ext cx="7772400" cy="0"/>
+            <a:ext cx="7254240" cy="0"/>
           </a:xfrm>
           <a:prstGeom prst="line">
             <a:avLst/>
@@ -7854,8 +7874,8 @@
         </p:nvCxnSpPr>
         <p:spPr>
           <a:xfrm>
-            <a:off x="8686800" y="3810000"/>
-            <a:ext cx="2590800" cy="0"/>
+            <a:off x="8168640" y="3810000"/>
+            <a:ext cx="3108960" cy="0"/>
           </a:xfrm>
           <a:prstGeom prst="line">
             <a:avLst/>
@@ -7889,8 +7909,8 @@
         </p:nvSpPr>
         <p:spPr>
           <a:xfrm>
-            <a:off x="533400" y="3962400"/>
-            <a:ext cx="762000" cy="254000"/>
+            <a:off x="482600" y="3962400"/>
+            <a:ext cx="863600" cy="279400"/>
           </a:xfrm>
           <a:prstGeom prst="rect">
             <a:avLst/>
@@ -7912,7 +7932,7 @@
               </a:spcAft>
             </a:pPr>
             <a:r>
-              <a:rPr sz="1600" b="0">
+              <a:rPr sz="1800" b="0">
                 <a:solidFill>
                   <a:srgbClr val="5B5F69"/>
                 </a:solidFill>
@@ -7931,8 +7951,8 @@
         </p:nvSpPr>
         <p:spPr>
           <a:xfrm>
-            <a:off x="2260600" y="3962400"/>
-            <a:ext cx="762000" cy="254000"/>
+            <a:off x="2209800" y="3962400"/>
+            <a:ext cx="863600" cy="279400"/>
           </a:xfrm>
           <a:prstGeom prst="rect">
             <a:avLst/>
@@ -7954,7 +7974,7 @@
               </a:spcAft>
             </a:pPr>
             <a:r>
-              <a:rPr sz="1600" b="0">
+              <a:rPr sz="1800" b="0">
                 <a:solidFill>
                   <a:srgbClr val="5B5F69"/>
                 </a:solidFill>
@@ -7973,8 +7993,8 @@
         </p:nvSpPr>
         <p:spPr>
           <a:xfrm>
-            <a:off x="3987800" y="3962400"/>
-            <a:ext cx="762000" cy="254000"/>
+            <a:off x="3937000" y="3962400"/>
+            <a:ext cx="863600" cy="279400"/>
           </a:xfrm>
           <a:prstGeom prst="rect">
             <a:avLst/>
@@ -7996,7 +8016,7 @@
               </a:spcAft>
             </a:pPr>
             <a:r>
-              <a:rPr sz="1600" b="0">
+              <a:rPr sz="1800" b="0">
                 <a:solidFill>
                   <a:srgbClr val="5B5F69"/>
                 </a:solidFill>
@@ -8015,8 +8035,8 @@
         </p:nvSpPr>
         <p:spPr>
           <a:xfrm>
-            <a:off x="5715000" y="3962400"/>
-            <a:ext cx="762000" cy="254000"/>
+            <a:off x="5664200" y="3962400"/>
+            <a:ext cx="863600" cy="279400"/>
           </a:xfrm>
           <a:prstGeom prst="rect">
             <a:avLst/>
@@ -8038,7 +8058,7 @@
               </a:spcAft>
             </a:pPr>
             <a:r>
-              <a:rPr sz="1600" b="0">
+              <a:rPr sz="1800" b="0">
                 <a:solidFill>
                   <a:srgbClr val="5B5F69"/>
                 </a:solidFill>
@@ -8057,8 +8077,8 @@
         </p:nvSpPr>
         <p:spPr>
           <a:xfrm>
-            <a:off x="7442200" y="3962400"/>
-            <a:ext cx="762000" cy="254000"/>
+            <a:off x="7391400" y="3962400"/>
+            <a:ext cx="863600" cy="279400"/>
           </a:xfrm>
           <a:prstGeom prst="rect">
             <a:avLst/>
@@ -8080,7 +8100,7 @@
               </a:spcAft>
             </a:pPr>
             <a:r>
-              <a:rPr sz="1600" b="0">
+              <a:rPr sz="1800" b="0">
                 <a:solidFill>
                   <a:srgbClr val="5B5F69"/>
                 </a:solidFill>
@@ -8099,8 +8119,8 @@
         </p:nvSpPr>
         <p:spPr>
           <a:xfrm>
-            <a:off x="9169400" y="3962400"/>
-            <a:ext cx="762000" cy="254000"/>
+            <a:off x="9118600" y="3962400"/>
+            <a:ext cx="863600" cy="279400"/>
           </a:xfrm>
           <a:prstGeom prst="rect">
             <a:avLst/>
@@ -8122,7 +8142,7 @@
               </a:spcAft>
             </a:pPr>
             <a:r>
-              <a:rPr sz="1600" b="0">
+              <a:rPr sz="1800" b="0">
                 <a:solidFill>
                   <a:srgbClr val="5B5F69"/>
                 </a:solidFill>
@@ -8141,8 +8161,8 @@
         </p:nvSpPr>
         <p:spPr>
           <a:xfrm>
-            <a:off x="10896600" y="3962400"/>
-            <a:ext cx="762000" cy="254000"/>
+            <a:off x="10845800" y="3962400"/>
+            <a:ext cx="863600" cy="279400"/>
           </a:xfrm>
           <a:prstGeom prst="rect">
             <a:avLst/>
@@ -8164,7 +8184,7 @@
               </a:spcAft>
             </a:pPr>
             <a:r>
-              <a:rPr sz="1600" b="0">
+              <a:rPr sz="1800" b="0">
                 <a:solidFill>
                   <a:srgbClr val="5B5F69"/>
                 </a:solidFill>
@@ -8183,8 +8203,8 @@
         </p:nvSpPr>
         <p:spPr>
           <a:xfrm>
-            <a:off x="914400" y="4318000"/>
-            <a:ext cx="5080000" cy="254000"/>
+            <a:off x="1143000" y="3403600"/>
+            <a:ext cx="3683000" cy="279400"/>
           </a:xfrm>
           <a:prstGeom prst="rect">
             <a:avLst/>
@@ -8206,13 +8226,13 @@
               </a:spcAft>
             </a:pPr>
             <a:r>
-              <a:rPr sz="1600" b="0">
+              <a:rPr sz="1800" b="0">
                 <a:solidFill>
                   <a:srgbClr val="3B3E46"/>
                 </a:solidFill>
                 <a:latin typeface="Arial"/>
               </a:rPr>
-              <a:t>Fichiers HTML envoyés par mail en ZIP</a:t>
+              <a:t>Pages HTML envoyées en ZIP</a:t>
             </a:r>
           </a:p>
         </p:txBody>
@@ -8225,8 +8245,8 @@
         </p:nvSpPr>
         <p:spPr>
           <a:xfrm>
-            <a:off x="8686800" y="4318000"/>
-            <a:ext cx="4191000" cy="254000"/>
+            <a:off x="7772400" y="3403600"/>
+            <a:ext cx="3302000" cy="279400"/>
           </a:xfrm>
           <a:prstGeom prst="rect">
             <a:avLst/>
@@ -8239,16 +8259,16 @@
           </a:bodyPr>
           <a:lstStyle/>
           <a:p>
-            <a:pPr algn="l">
-              <a:lnSpc>
-                <a:spcPct val="110000"/>
-              </a:lnSpc>
-              <a:spcAft>
-                <a:spcPts val="0"/>
-              </a:spcAft>
-            </a:pPr>
-            <a:r>
-              <a:rPr sz="1600" b="1">
+            <a:pPr algn="r">
+              <a:lnSpc>
+                <a:spcPct val="110000"/>
+              </a:lnSpc>
+              <a:spcAft>
+                <a:spcPts val="0"/>
+              </a:spcAft>
+            </a:pPr>
+            <a:r>
+              <a:rPr sz="1800" b="1">
                 <a:solidFill>
                   <a:srgbClr val="1C1E21"/>
                 </a:solidFill>
@@ -8274,10 +8294,12 @@
             <a:avLst/>
           </a:prstGeom>
           <a:solidFill>
-            <a:srgbClr val="1B1C1F"/>
+            <a:srgbClr val="F3F0E7"/>
           </a:solidFill>
-          <a:ln>
-            <a:noFill/>
+          <a:ln w="25400">
+            <a:solidFill>
+              <a:srgbClr val="1B1C1F"/>
+            </a:solidFill>
           </a:ln>
           <a:effectLst/>
         </p:spPr>
@@ -8311,8 +8333,8 @@
         </p:nvCxnSpPr>
         <p:spPr>
           <a:xfrm>
-            <a:off x="914400" y="2794000"/>
-            <a:ext cx="0" cy="889000"/>
+            <a:off x="914400" y="2819400"/>
+            <a:ext cx="0" cy="863600"/>
           </a:xfrm>
           <a:prstGeom prst="line">
             <a:avLst/>
@@ -8346,8 +8368,8 @@
         </p:nvSpPr>
         <p:spPr>
           <a:xfrm>
-            <a:off x="-228600" y="1905000"/>
-            <a:ext cx="2286000" cy="889000"/>
+            <a:off x="609600" y="1905000"/>
+            <a:ext cx="2540000" cy="889000"/>
           </a:xfrm>
           <a:prstGeom prst="rect">
             <a:avLst/>
@@ -8360,7 +8382,7 @@
           </a:bodyPr>
           <a:lstStyle/>
           <a:p>
-            <a:pPr algn="ctr">
+            <a:pPr algn="l">
               <a:lnSpc>
                 <a:spcPct val="110000"/>
               </a:lnSpc>
@@ -8379,16 +8401,16 @@
             </a:r>
           </a:p>
           <a:p>
-            <a:pPr algn="ctr">
-              <a:lnSpc>
-                <a:spcPct val="110000"/>
-              </a:lnSpc>
-              <a:spcAft>
-                <a:spcPts val="0"/>
-              </a:spcAft>
-            </a:pPr>
-            <a:r>
-              <a:rPr sz="1600" b="0">
+            <a:pPr algn="l">
+              <a:lnSpc>
+                <a:spcPct val="110000"/>
+              </a:lnSpc>
+              <a:spcAft>
+                <a:spcPts val="0"/>
+              </a:spcAft>
+            </a:pPr>
+            <a:r>
+              <a:rPr sz="1800" b="0">
                 <a:solidFill>
                   <a:srgbClr val="3B3E46"/>
                 </a:solidFill>
@@ -8414,10 +8436,12 @@
             <a:avLst/>
           </a:prstGeom>
           <a:solidFill>
-            <a:srgbClr val="1B1C1F"/>
+            <a:srgbClr val="F3F0E7"/>
           </a:solidFill>
-          <a:ln>
-            <a:noFill/>
+          <a:ln w="25400">
+            <a:solidFill>
+              <a:srgbClr val="1B1C1F"/>
+            </a:solidFill>
           </a:ln>
           <a:effectLst/>
         </p:spPr>
@@ -8450,9 +8474,9 @@
           <p:nvPr/>
         </p:nvCxnSpPr>
         <p:spPr>
-          <a:xfrm flipV="1">
-            <a:off x="2641600" y="4699000"/>
-            <a:ext cx="0" cy="177800"/>
+          <a:xfrm>
+            <a:off x="2641600" y="4318000"/>
+            <a:ext cx="0" cy="558800"/>
           </a:xfrm>
           <a:prstGeom prst="line">
             <a:avLst/>
@@ -8486,8 +8510,8 @@
         </p:nvSpPr>
         <p:spPr>
           <a:xfrm>
-            <a:off x="1498600" y="5207000"/>
-            <a:ext cx="2286000" cy="889000"/>
+            <a:off x="990600" y="4953000"/>
+            <a:ext cx="3302000" cy="889000"/>
           </a:xfrm>
           <a:prstGeom prst="rect">
             <a:avLst/>
@@ -8528,7 +8552,7 @@
               </a:spcAft>
             </a:pPr>
             <a:r>
-              <a:rPr sz="1600" b="0">
+              <a:rPr sz="1800" b="0">
                 <a:solidFill>
                   <a:srgbClr val="3B3E46"/>
                 </a:solidFill>
@@ -8554,10 +8578,12 @@
             <a:avLst/>
           </a:prstGeom>
           <a:solidFill>
-            <a:srgbClr val="1B1C1F"/>
+            <a:srgbClr val="F3F0E7"/>
           </a:solidFill>
-          <a:ln>
-            <a:noFill/>
+          <a:ln w="25400">
+            <a:solidFill>
+              <a:srgbClr val="1B1C1F"/>
+            </a:solidFill>
           </a:ln>
           <a:effectLst/>
         </p:spPr>
@@ -8591,8 +8617,8 @@
         </p:nvCxnSpPr>
         <p:spPr>
           <a:xfrm>
-            <a:off x="4886959" y="2794000"/>
-            <a:ext cx="0" cy="889000"/>
+            <a:off x="4886959" y="2819400"/>
+            <a:ext cx="0" cy="863600"/>
           </a:xfrm>
           <a:prstGeom prst="line">
             <a:avLst/>
@@ -8626,8 +8652,8 @@
         </p:nvSpPr>
         <p:spPr>
           <a:xfrm>
-            <a:off x="3743959" y="1905000"/>
-            <a:ext cx="2286000" cy="889000"/>
+            <a:off x="3616959" y="1905000"/>
+            <a:ext cx="2540000" cy="889000"/>
           </a:xfrm>
           <a:prstGeom prst="rect">
             <a:avLst/>
@@ -8668,7 +8694,7 @@
               </a:spcAft>
             </a:pPr>
             <a:r>
-              <a:rPr sz="1600" b="0">
+              <a:rPr sz="1800" b="0">
                 <a:solidFill>
                   <a:srgbClr val="3B3E46"/>
                 </a:solidFill>
@@ -8694,10 +8720,12 @@
             <a:avLst/>
           </a:prstGeom>
           <a:solidFill>
-            <a:srgbClr val="1B1C1F"/>
+            <a:srgbClr val="F3F0E7"/>
           </a:solidFill>
-          <a:ln>
-            <a:noFill/>
+          <a:ln w="25400">
+            <a:solidFill>
+              <a:srgbClr val="1B1C1F"/>
+            </a:solidFill>
           </a:ln>
           <a:effectLst/>
         </p:spPr>
@@ -8730,9 +8758,9 @@
           <p:nvPr/>
         </p:nvCxnSpPr>
         <p:spPr>
-          <a:xfrm flipV="1">
-            <a:off x="8168640" y="4699000"/>
-            <a:ext cx="0" cy="177800"/>
+          <a:xfrm>
+            <a:off x="8168640" y="4318000"/>
+            <a:ext cx="0" cy="558800"/>
           </a:xfrm>
           <a:prstGeom prst="line">
             <a:avLst/>
@@ -8766,8 +8794,8 @@
         </p:nvSpPr>
         <p:spPr>
           <a:xfrm>
-            <a:off x="7025640" y="5207000"/>
-            <a:ext cx="2286000" cy="889000"/>
+            <a:off x="6517640" y="4953000"/>
+            <a:ext cx="3302000" cy="889000"/>
           </a:xfrm>
           <a:prstGeom prst="rect">
             <a:avLst/>
@@ -8808,7 +8836,7 @@
               </a:spcAft>
             </a:pPr>
             <a:r>
-              <a:rPr sz="1600" b="0">
+              <a:rPr sz="1800" b="0">
                 <a:solidFill>
                   <a:srgbClr val="3B3E46"/>
                 </a:solidFill>
@@ -8827,8 +8855,8 @@
         </p:nvSpPr>
         <p:spPr>
           <a:xfrm>
-            <a:off x="11176000" y="3708400"/>
-            <a:ext cx="203200" cy="203200"/>
+            <a:off x="11150600" y="3683000"/>
+            <a:ext cx="254000" cy="254000"/>
           </a:xfrm>
           <a:prstGeom prst="ellipse">
             <a:avLst/>
@@ -8871,8 +8899,8 @@
         </p:nvCxnSpPr>
         <p:spPr>
           <a:xfrm>
-            <a:off x="11277600" y="2794000"/>
-            <a:ext cx="0" cy="889000"/>
+            <a:off x="11277600" y="2819400"/>
+            <a:ext cx="0" cy="863600"/>
           </a:xfrm>
           <a:prstGeom prst="line">
             <a:avLst/>
@@ -8906,8 +8934,8 @@
         </p:nvSpPr>
         <p:spPr>
           <a:xfrm>
-            <a:off x="10134600" y="1905000"/>
-            <a:ext cx="2286000" cy="889000"/>
+            <a:off x="9042400" y="1905000"/>
+            <a:ext cx="2540000" cy="889000"/>
           </a:xfrm>
           <a:prstGeom prst="rect">
             <a:avLst/>
@@ -8920,7 +8948,7 @@
           </a:bodyPr>
           <a:lstStyle/>
           <a:p>
-            <a:pPr algn="ctr">
+            <a:pPr algn="r">
               <a:lnSpc>
                 <a:spcPct val="110000"/>
               </a:lnSpc>
@@ -8939,16 +8967,16 @@
             </a:r>
           </a:p>
           <a:p>
-            <a:pPr algn="ctr">
-              <a:lnSpc>
-                <a:spcPct val="110000"/>
-              </a:lnSpc>
-              <a:spcAft>
-                <a:spcPts val="0"/>
-              </a:spcAft>
-            </a:pPr>
-            <a:r>
-              <a:rPr sz="1600" b="0">
+            <a:pPr algn="r">
+              <a:lnSpc>
+                <a:spcPct val="110000"/>
+              </a:lnSpc>
+              <a:spcAft>
+                <a:spcPts val="0"/>
+              </a:spcAft>
+            </a:pPr>
+            <a:r>
+              <a:rPr sz="1800" b="0">
                 <a:solidFill>
                   <a:srgbClr val="3B3E46"/>
                 </a:solidFill>
@@ -8967,7 +8995,7 @@
         </p:nvSpPr>
         <p:spPr>
           <a:xfrm>
-            <a:off x="609600" y="6477000"/>
+            <a:off x="609600" y="6413500"/>
             <a:ext cx="7620000" cy="203200"/>
           </a:xfrm>
           <a:prstGeom prst="rect">
@@ -9009,7 +9037,7 @@
         </p:nvSpPr>
         <p:spPr>
           <a:xfrm>
-            <a:off x="10312400" y="6477000"/>
+            <a:off x="10312400" y="6413500"/>
             <a:ext cx="1270000" cy="203200"/>
           </a:xfrm>
           <a:prstGeom prst="rect">
@@ -9106,7 +9134,26 @@
                 </a:solidFill>
                 <a:latin typeface="Arial"/>
               </a:rPr>
-              <a:t>D'un ZIP envoyé par mail à une plateforme unique, mise à jour en direct</a:t>
+              <a:t>D’un ZIP envoyé par mail à une plateforme unique,</a:t>
+            </a:r>
+          </a:p>
+          <a:p>
+            <a:pPr algn="l">
+              <a:lnSpc>
+                <a:spcPct val="105000"/>
+              </a:lnSpc>
+              <a:spcAft>
+                <a:spcPts val="0"/>
+              </a:spcAft>
+            </a:pPr>
+            <a:r>
+              <a:rPr sz="3200" b="1">
+                <a:solidFill>
+                  <a:srgbClr val="14140F"/>
+                </a:solidFill>
+                <a:latin typeface="Arial"/>
+              </a:rPr>
+              <a:t>mise à jour en direct</a:t>
             </a:r>
           </a:p>
         </p:txBody>
@@ -9360,7 +9407,7 @@
                 </a:solidFill>
                 <a:latin typeface="Arial"/>
               </a:rPr>
-              <a:t>une zone en quelques minutes</a:t>
+              <a:t>une zone en minutes</a:t>
             </a:r>
           </a:p>
         </p:txBody>
@@ -9444,7 +9491,7 @@
                 </a:solidFill>
                 <a:latin typeface="Arial"/>
               </a:rPr>
-              <a:t>fiches faites deux fois</a:t>
+              <a:t>fiches en double</a:t>
             </a:r>
           </a:p>
         </p:txBody>
@@ -9486,7 +9533,7 @@
                 </a:solidFill>
                 <a:latin typeface="Arial"/>
               </a:rPr>
-              <a:t>une fiche, la même partout (≈ 4 000)</a:t>
+              <a:t>une seule fiche (≈ 4 000)</a:t>
             </a:r>
           </a:p>
         </p:txBody>
@@ -9766,7 +9813,7 @@
                 </a:solidFill>
                 <a:latin typeface="Arial"/>
               </a:rPr>
-              <a:t>JEMM recopié à la main</a:t>
+              <a:t>JEMM recopié</a:t>
             </a:r>
           </a:p>
         </p:txBody>
@@ -9927,7 +9974,7 @@
                 </a:solidFill>
                 <a:latin typeface="Arial"/>
               </a:rPr>
-              <a:t>impact non mesurable</a:t>
+              <a:t>impact non mesuré</a:t>
             </a:r>
           </a:p>
         </p:txBody>
@@ -10017,7 +10064,7 @@
         </p:nvSpPr>
         <p:spPr>
           <a:xfrm>
-            <a:off x="609600" y="6477000"/>
+            <a:off x="609600" y="6413500"/>
             <a:ext cx="7620000" cy="203200"/>
           </a:xfrm>
           <a:prstGeom prst="rect">
@@ -10059,7 +10106,7 @@
         </p:nvSpPr>
         <p:spPr>
           <a:xfrm>
-            <a:off x="10312400" y="6477000"/>
+            <a:off x="10312400" y="6413500"/>
             <a:ext cx="1270000" cy="203200"/>
           </a:xfrm>
           <a:prstGeom prst="rect">
@@ -10156,7 +10203,26 @@
                 </a:solidFill>
                 <a:latin typeface="Arial"/>
               </a:rPr>
-              <a:t>Une zone par exercice : les applications à la carte, une seule identité partout</a:t>
+              <a:t>Une zone par exercice : les applications à la carte,</a:t>
+            </a:r>
+          </a:p>
+          <a:p>
+            <a:pPr algn="l">
+              <a:lnSpc>
+                <a:spcPct val="105000"/>
+              </a:lnSpc>
+              <a:spcAft>
+                <a:spcPts val="0"/>
+              </a:spcAft>
+            </a:pPr>
+            <a:r>
+              <a:rPr sz="3200" b="1">
+                <a:solidFill>
+                  <a:srgbClr val="14140F"/>
+                </a:solidFill>
+                <a:latin typeface="Arial"/>
+              </a:rPr>
+              <a:t>une seule identité partout</a:t>
             </a:r>
           </a:p>
         </p:txBody>
@@ -10214,7 +10280,7 @@
         <p:spPr>
           <a:xfrm>
             <a:off x="1117600" y="1930400"/>
-            <a:ext cx="5080000" cy="254000"/>
+            <a:ext cx="5080000" cy="279400"/>
           </a:xfrm>
           <a:prstGeom prst="rect">
             <a:avLst/>
@@ -10236,13 +10302,13 @@
               </a:spcAft>
             </a:pPr>
             <a:r>
-              <a:rPr sz="1600" b="1">
+              <a:rPr sz="1800" b="1">
                 <a:solidFill>
                   <a:srgbClr val="3B3E46"/>
                 </a:solidFill>
                 <a:latin typeface="Arial"/>
               </a:rPr>
-              <a:t>Zone « DELATTRE 26 »</a:t>
+              <a:t>Zone « DELATTRE 26 »</a:t>
             </a:r>
           </a:p>
         </p:txBody>
@@ -10255,8 +10321,8 @@
         </p:nvSpPr>
         <p:spPr>
           <a:xfrm>
-            <a:off x="660400" y="3683000"/>
-            <a:ext cx="508000" cy="508000"/>
+            <a:off x="609600" y="3683000"/>
+            <a:ext cx="609600" cy="508000"/>
           </a:xfrm>
           <a:prstGeom prst="rect">
             <a:avLst/>
@@ -10301,8 +10367,8 @@
         </p:nvSpPr>
         <p:spPr>
           <a:xfrm>
-            <a:off x="660400" y="3683000"/>
-            <a:ext cx="508000" cy="508000"/>
+            <a:off x="609600" y="3683000"/>
+            <a:ext cx="609600" cy="508000"/>
           </a:xfrm>
           <a:prstGeom prst="rect">
             <a:avLst/>
@@ -10324,7 +10390,7 @@
               </a:spcAft>
             </a:pPr>
             <a:r>
-              <a:rPr sz="1200" b="1">
+              <a:rPr sz="1800" b="1">
                 <a:solidFill>
                   <a:srgbClr val="1C1E21"/>
                 </a:solidFill>
@@ -10344,7 +10410,7 @@
         <p:spPr>
           <a:xfrm>
             <a:off x="1422400" y="2311400"/>
-            <a:ext cx="3175000" cy="304800"/>
+            <a:ext cx="3048000" cy="304800"/>
           </a:xfrm>
           <a:prstGeom prst="rect">
             <a:avLst/>
@@ -10386,7 +10452,7 @@
         <p:spPr>
           <a:xfrm>
             <a:off x="1422400" y="2717800"/>
-            <a:ext cx="3175000" cy="533400"/>
+            <a:ext cx="3048000" cy="533400"/>
           </a:xfrm>
           <a:prstGeom prst="rect">
             <a:avLst/>
@@ -10432,7 +10498,7 @@
         <p:spPr>
           <a:xfrm>
             <a:off x="1600200" y="2717800"/>
-            <a:ext cx="2921000" cy="533400"/>
+            <a:ext cx="2794000" cy="533400"/>
           </a:xfrm>
           <a:prstGeom prst="rect">
             <a:avLst/>
@@ -10474,7 +10540,7 @@
         <p:spPr>
           <a:xfrm>
             <a:off x="1422400" y="3378200"/>
-            <a:ext cx="3175000" cy="533400"/>
+            <a:ext cx="3048000" cy="533400"/>
           </a:xfrm>
           <a:prstGeom prst="rect">
             <a:avLst/>
@@ -10520,7 +10586,7 @@
         <p:spPr>
           <a:xfrm>
             <a:off x="1600200" y="3378200"/>
-            <a:ext cx="2921000" cy="533400"/>
+            <a:ext cx="2794000" cy="533400"/>
           </a:xfrm>
           <a:prstGeom prst="rect">
             <a:avLst/>
@@ -10562,7 +10628,7 @@
         <p:spPr>
           <a:xfrm>
             <a:off x="1422400" y="4038600"/>
-            <a:ext cx="3175000" cy="533400"/>
+            <a:ext cx="3048000" cy="533400"/>
           </a:xfrm>
           <a:prstGeom prst="rect">
             <a:avLst/>
@@ -10608,7 +10674,7 @@
         <p:spPr>
           <a:xfrm>
             <a:off x="1600200" y="4038600"/>
-            <a:ext cx="2921000" cy="533400"/>
+            <a:ext cx="2794000" cy="533400"/>
           </a:xfrm>
           <a:prstGeom prst="rect">
             <a:avLst/>
@@ -10649,8 +10715,8 @@
         </p:nvSpPr>
         <p:spPr>
           <a:xfrm>
-            <a:off x="4851400" y="2311400"/>
-            <a:ext cx="3175000" cy="304800"/>
+            <a:off x="4749800" y="2311400"/>
+            <a:ext cx="3048000" cy="304800"/>
           </a:xfrm>
           <a:prstGeom prst="rect">
             <a:avLst/>
@@ -10691,8 +10757,8 @@
         </p:nvSpPr>
         <p:spPr>
           <a:xfrm>
-            <a:off x="4851400" y="2717800"/>
-            <a:ext cx="3175000" cy="533400"/>
+            <a:off x="4749800" y="2717800"/>
+            <a:ext cx="3048000" cy="533400"/>
           </a:xfrm>
           <a:prstGeom prst="rect">
             <a:avLst/>
@@ -10737,8 +10803,8 @@
         </p:nvSpPr>
         <p:spPr>
           <a:xfrm>
-            <a:off x="5029200" y="2717800"/>
-            <a:ext cx="2921000" cy="533400"/>
+            <a:off x="4927600" y="2717800"/>
+            <a:ext cx="2794000" cy="533400"/>
           </a:xfrm>
           <a:prstGeom prst="rect">
             <a:avLst/>
@@ -10779,8 +10845,8 @@
         </p:nvSpPr>
         <p:spPr>
           <a:xfrm>
-            <a:off x="4851400" y="3378200"/>
-            <a:ext cx="3175000" cy="533400"/>
+            <a:off x="4749800" y="3378200"/>
+            <a:ext cx="3048000" cy="533400"/>
           </a:xfrm>
           <a:prstGeom prst="rect">
             <a:avLst/>
@@ -10825,8 +10891,8 @@
         </p:nvSpPr>
         <p:spPr>
           <a:xfrm>
-            <a:off x="5029200" y="3378200"/>
-            <a:ext cx="2921000" cy="533400"/>
+            <a:off x="4927600" y="3378200"/>
+            <a:ext cx="2794000" cy="533400"/>
           </a:xfrm>
           <a:prstGeom prst="rect">
             <a:avLst/>
@@ -10867,8 +10933,8 @@
         </p:nvSpPr>
         <p:spPr>
           <a:xfrm>
-            <a:off x="4851400" y="4038600"/>
-            <a:ext cx="3175000" cy="533400"/>
+            <a:off x="4749800" y="4038600"/>
+            <a:ext cx="3048000" cy="533400"/>
           </a:xfrm>
           <a:prstGeom prst="rect">
             <a:avLst/>
@@ -10913,8 +10979,8 @@
         </p:nvSpPr>
         <p:spPr>
           <a:xfrm>
-            <a:off x="5029200" y="4038600"/>
-            <a:ext cx="2921000" cy="533400"/>
+            <a:off x="4927600" y="4038600"/>
+            <a:ext cx="2794000" cy="533400"/>
           </a:xfrm>
           <a:prstGeom prst="rect">
             <a:avLst/>
@@ -10955,8 +11021,8 @@
         </p:nvSpPr>
         <p:spPr>
           <a:xfrm>
-            <a:off x="8280400" y="2311400"/>
-            <a:ext cx="3175000" cy="304800"/>
+            <a:off x="8077200" y="2311400"/>
+            <a:ext cx="3048000" cy="304800"/>
           </a:xfrm>
           <a:prstGeom prst="rect">
             <a:avLst/>
@@ -10997,8 +11063,8 @@
         </p:nvSpPr>
         <p:spPr>
           <a:xfrm>
-            <a:off x="8280400" y="2717800"/>
-            <a:ext cx="3175000" cy="533400"/>
+            <a:off x="8077200" y="2717800"/>
+            <a:ext cx="3048000" cy="533400"/>
           </a:xfrm>
           <a:prstGeom prst="rect">
             <a:avLst/>
@@ -11043,8 +11109,8 @@
         </p:nvSpPr>
         <p:spPr>
           <a:xfrm>
-            <a:off x="8458200" y="2717800"/>
-            <a:ext cx="2921000" cy="533400"/>
+            <a:off x="8255000" y="2717800"/>
+            <a:ext cx="2794000" cy="533400"/>
           </a:xfrm>
           <a:prstGeom prst="rect">
             <a:avLst/>
@@ -11085,8 +11151,8 @@
         </p:nvSpPr>
         <p:spPr>
           <a:xfrm>
-            <a:off x="8280400" y="3378200"/>
-            <a:ext cx="3175000" cy="533400"/>
+            <a:off x="8077200" y="3378200"/>
+            <a:ext cx="3048000" cy="533400"/>
           </a:xfrm>
           <a:prstGeom prst="rect">
             <a:avLst/>
@@ -11131,8 +11197,8 @@
         </p:nvSpPr>
         <p:spPr>
           <a:xfrm>
-            <a:off x="8458200" y="3378200"/>
-            <a:ext cx="2921000" cy="533400"/>
+            <a:off x="8255000" y="3378200"/>
+            <a:ext cx="2794000" cy="533400"/>
           </a:xfrm>
           <a:prstGeom prst="rect">
             <a:avLst/>
@@ -11174,7 +11240,7 @@
         <p:spPr>
           <a:xfrm>
             <a:off x="1422400" y="4876800"/>
-            <a:ext cx="10033000" cy="660400"/>
+            <a:ext cx="9702800" cy="660400"/>
           </a:xfrm>
           <a:prstGeom prst="rect">
             <a:avLst/>
@@ -11218,7 +11284,7 @@
         <p:spPr>
           <a:xfrm>
             <a:off x="1676400" y="4876800"/>
-            <a:ext cx="9652000" cy="660400"/>
+            <a:ext cx="9321800" cy="660400"/>
           </a:xfrm>
           <a:prstGeom prst="rect">
             <a:avLst/>
@@ -11246,7 +11312,7 @@
                 </a:solidFill>
                 <a:latin typeface="Arial"/>
               </a:rPr>
-              <a:t>EHO : chaque personnage existe une fois, avec la même identité dans toutes les applications</a:t>
+              <a:t>EHO : chaque personnage existe une fois, même identité partout</a:t>
             </a:r>
           </a:p>
         </p:txBody>
@@ -11259,7 +11325,7 @@
         </p:nvSpPr>
         <p:spPr>
           <a:xfrm>
-            <a:off x="609600" y="6477000"/>
+            <a:off x="609600" y="6413500"/>
             <a:ext cx="7620000" cy="203200"/>
           </a:xfrm>
           <a:prstGeom prst="rect">
@@ -11301,7 +11367,7 @@
         </p:nvSpPr>
         <p:spPr>
           <a:xfrm>
-            <a:off x="10312400" y="6477000"/>
+            <a:off x="10312400" y="6413500"/>
             <a:ext cx="1270000" cy="203200"/>
           </a:xfrm>
           <a:prstGeom prst="rect">
@@ -11398,7 +11464,7 @@
                 </a:solidFill>
                 <a:latin typeface="Arial"/>
               </a:rPr>
-              <a:t>Du plan JEMM à l'écran des joueurs, dans un seul circuit</a:t>
+              <a:t>Du plan JEMM à l’écran des joueurs, dans un seul circuit</a:t>
             </a:r>
           </a:p>
         </p:txBody>
@@ -11411,8 +11477,8 @@
         </p:nvSpPr>
         <p:spPr>
           <a:xfrm>
-            <a:off x="609600" y="2159000"/>
-            <a:ext cx="1574800" cy="2032000"/>
+            <a:off x="609600" y="2184400"/>
+            <a:ext cx="1524000" cy="2032000"/>
           </a:xfrm>
           <a:prstGeom prst="rect">
             <a:avLst/>
@@ -11457,7 +11523,7 @@
         </p:nvSpPr>
         <p:spPr>
           <a:xfrm>
-            <a:off x="762000" y="2311400"/>
+            <a:off x="736600" y="2336800"/>
             <a:ext cx="1270000" cy="304800"/>
           </a:xfrm>
           <a:prstGeom prst="rect">
@@ -11499,8 +11565,8 @@
         </p:nvSpPr>
         <p:spPr>
           <a:xfrm>
-            <a:off x="762000" y="2717800"/>
-            <a:ext cx="1270000" cy="1397000"/>
+            <a:off x="736600" y="2743200"/>
+            <a:ext cx="1320800" cy="1397000"/>
           </a:xfrm>
           <a:prstGeom prst="rect">
             <a:avLst/>
@@ -11541,13 +11607,13 @@
               </a:spcAft>
             </a:pPr>
             <a:r>
-              <a:rPr sz="1600" b="0">
+              <a:rPr sz="1800" b="0">
                 <a:solidFill>
                   <a:srgbClr val="3B3E46"/>
                 </a:solidFill>
                 <a:latin typeface="Arial"/>
               </a:rPr>
-              <a:t>l'incident est planifié</a:t>
+              <a:t>l’incident est planifié</a:t>
             </a:r>
           </a:p>
         </p:txBody>
@@ -11560,8 +11626,8 @@
         </p:nvSpPr>
         <p:spPr>
           <a:xfrm>
-            <a:off x="2235200" y="3048000"/>
-            <a:ext cx="203200" cy="254000"/>
+            <a:off x="2176780" y="3073400"/>
+            <a:ext cx="279400" cy="254000"/>
           </a:xfrm>
           <a:prstGeom prst="rightArrow">
             <a:avLst/>
@@ -11604,199 +11670,8 @@
         </p:nvSpPr>
         <p:spPr>
           <a:xfrm>
-            <a:off x="2489200" y="2159000"/>
-            <a:ext cx="1574800" cy="2032000"/>
-          </a:xfrm>
-          <a:prstGeom prst="rect">
-            <a:avLst/>
-          </a:prstGeom>
-          <a:solidFill>
-            <a:srgbClr val="1B1C1F"/>
-          </a:solidFill>
-          <a:ln>
-            <a:noFill/>
-          </a:ln>
-          <a:effectLst/>
-        </p:spPr>
-        <p:style>
-          <a:lnRef idx="1">
-            <a:schemeClr val="accent1"/>
-          </a:lnRef>
-          <a:fillRef idx="3">
-            <a:schemeClr val="accent1"/>
-          </a:fillRef>
-          <a:effectRef idx="2">
-            <a:schemeClr val="accent1"/>
-          </a:effectRef>
-          <a:fontRef idx="minor">
-            <a:schemeClr val="lt1"/>
-          </a:fontRef>
-        </p:style>
-        <p:txBody>
-          <a:bodyPr rtlCol="0" anchor="ctr"/>
-          <a:lstStyle/>
-          <a:p>
-            <a:pPr algn="ctr"/>
-          </a:p>
-        </p:txBody>
-      </p:sp>
-      <p:sp>
-        <p:nvSpPr>
-          <p:cNvPr id="8" name="TextBox 7"/>
-          <p:cNvSpPr txBox="1"/>
-          <p:nvPr/>
-        </p:nvSpPr>
-        <p:spPr>
-          <a:xfrm>
-            <a:off x="2641600" y="2311400"/>
-            <a:ext cx="1270000" cy="304800"/>
-          </a:xfrm>
-          <a:prstGeom prst="rect">
-            <a:avLst/>
-          </a:prstGeom>
-          <a:noFill/>
-        </p:spPr>
-        <p:txBody>
-          <a:bodyPr wrap="square" lIns="0" rIns="0" tIns="0" bIns="0" anchor="t">
-            <a:spAutoFit/>
-          </a:bodyPr>
-          <a:lstStyle/>
-          <a:p>
-            <a:pPr algn="l">
-              <a:lnSpc>
-                <a:spcPct val="110000"/>
-              </a:lnSpc>
-              <a:spcAft>
-                <a:spcPts val="0"/>
-              </a:spcAft>
-            </a:pPr>
-            <a:r>
-              <a:rPr sz="1800" b="1">
-                <a:solidFill>
-                  <a:srgbClr val="C3C8D8"/>
-                </a:solidFill>
-                <a:latin typeface="Arial"/>
-              </a:rPr>
-              <a:t>2</a:t>
-            </a:r>
-          </a:p>
-        </p:txBody>
-      </p:sp>
-      <p:sp>
-        <p:nvSpPr>
-          <p:cNvPr id="9" name="TextBox 8"/>
-          <p:cNvSpPr txBox="1"/>
-          <p:nvPr/>
-        </p:nvSpPr>
-        <p:spPr>
-          <a:xfrm>
-            <a:off x="2641600" y="2717800"/>
-            <a:ext cx="1270000" cy="1397000"/>
-          </a:xfrm>
-          <a:prstGeom prst="rect">
-            <a:avLst/>
-          </a:prstGeom>
-          <a:noFill/>
-        </p:spPr>
-        <p:txBody>
-          <a:bodyPr wrap="square" lIns="0" rIns="0" tIns="0" bIns="0" anchor="t">
-            <a:spAutoFit/>
-          </a:bodyPr>
-          <a:lstStyle/>
-          <a:p>
-            <a:pPr algn="l">
-              <a:lnSpc>
-                <a:spcPct val="110000"/>
-              </a:lnSpc>
-              <a:spcAft>
-                <a:spcPts val="0"/>
-              </a:spcAft>
-            </a:pPr>
-            <a:r>
-              <a:rPr sz="2000" b="1">
-                <a:solidFill>
-                  <a:srgbClr val="EDE3C8"/>
-                </a:solidFill>
-                <a:latin typeface="Arial"/>
-              </a:rPr>
-              <a:t>MELMIL</a:t>
-            </a:r>
-          </a:p>
-          <a:p>
-            <a:pPr algn="l">
-              <a:lnSpc>
-                <a:spcPct val="110000"/>
-              </a:lnSpc>
-              <a:spcAft>
-                <a:spcPts val="0"/>
-              </a:spcAft>
-            </a:pPr>
-            <a:r>
-              <a:rPr sz="1600" b="0">
-                <a:solidFill>
-                  <a:srgbClr val="C3C8D8"/>
-                </a:solidFill>
-                <a:latin typeface="Arial"/>
-              </a:rPr>
-              <a:t>on le prépare</a:t>
-            </a:r>
-          </a:p>
-        </p:txBody>
-      </p:sp>
-      <p:sp>
-        <p:nvSpPr>
-          <p:cNvPr id="10" name="Right Arrow 9"/>
-          <p:cNvSpPr/>
-          <p:nvPr/>
-        </p:nvSpPr>
-        <p:spPr>
-          <a:xfrm>
-            <a:off x="4114800" y="3048000"/>
-            <a:ext cx="203200" cy="254000"/>
-          </a:xfrm>
-          <a:prstGeom prst="rightArrow">
-            <a:avLst/>
-          </a:prstGeom>
-          <a:solidFill>
-            <a:srgbClr val="3B3E46"/>
-          </a:solidFill>
-          <a:ln>
-            <a:noFill/>
-          </a:ln>
-          <a:effectLst/>
-        </p:spPr>
-        <p:style>
-          <a:lnRef idx="1">
-            <a:schemeClr val="accent1"/>
-          </a:lnRef>
-          <a:fillRef idx="3">
-            <a:schemeClr val="accent1"/>
-          </a:fillRef>
-          <a:effectRef idx="2">
-            <a:schemeClr val="accent1"/>
-          </a:effectRef>
-          <a:fontRef idx="minor">
-            <a:schemeClr val="lt1"/>
-          </a:fontRef>
-        </p:style>
-        <p:txBody>
-          <a:bodyPr rtlCol="0" anchor="ctr"/>
-          <a:lstStyle/>
-          <a:p>
-            <a:pPr algn="ctr"/>
-          </a:p>
-        </p:txBody>
-      </p:sp>
-      <p:sp>
-        <p:nvSpPr>
-          <p:cNvPr id="11" name="Rectangle 10"/>
-          <p:cNvSpPr/>
-          <p:nvPr/>
-        </p:nvSpPr>
-        <p:spPr>
-          <a:xfrm>
-            <a:off x="4368800" y="2159000"/>
-            <a:ext cx="1574800" cy="2032000"/>
+            <a:off x="2499360" y="2184400"/>
+            <a:ext cx="1524000" cy="2032000"/>
           </a:xfrm>
           <a:prstGeom prst="rect">
             <a:avLst/>
@@ -11835,13 +11710,13 @@
       </p:sp>
       <p:sp>
         <p:nvSpPr>
-          <p:cNvPr id="12" name="TextBox 11"/>
+          <p:cNvPr id="8" name="TextBox 7"/>
           <p:cNvSpPr txBox="1"/>
           <p:nvPr/>
         </p:nvSpPr>
         <p:spPr>
           <a:xfrm>
-            <a:off x="4521200" y="2311400"/>
+            <a:off x="2626360" y="2336800"/>
             <a:ext cx="1270000" cy="304800"/>
           </a:xfrm>
           <a:prstGeom prst="rect">
@@ -11870,21 +11745,21 @@
                 </a:solidFill>
                 <a:latin typeface="Arial"/>
               </a:rPr>
-              <a:t>3</a:t>
-            </a:r>
-          </a:p>
-        </p:txBody>
-      </p:sp>
-      <p:sp>
-        <p:nvSpPr>
-          <p:cNvPr id="13" name="TextBox 12"/>
+              <a:t>2</a:t>
+            </a:r>
+          </a:p>
+        </p:txBody>
+      </p:sp>
+      <p:sp>
+        <p:nvSpPr>
+          <p:cNvPr id="9" name="TextBox 8"/>
           <p:cNvSpPr txBox="1"/>
           <p:nvPr/>
         </p:nvSpPr>
         <p:spPr>
           <a:xfrm>
-            <a:off x="4521200" y="2717800"/>
-            <a:ext cx="1270000" cy="1397000"/>
+            <a:off x="2626360" y="2743200"/>
+            <a:ext cx="1320800" cy="1397000"/>
           </a:xfrm>
           <a:prstGeom prst="rect">
             <a:avLst/>
@@ -11912,7 +11787,7 @@
                 </a:solidFill>
                 <a:latin typeface="Arial"/>
               </a:rPr>
-              <a:t>Animation</a:t>
+              <a:t>MELMIL</a:t>
             </a:r>
           </a:p>
           <a:p>
@@ -11925,27 +11800,27 @@
               </a:spcAft>
             </a:pPr>
             <a:r>
-              <a:rPr sz="1600" b="0">
+              <a:rPr sz="1800" b="0">
                 <a:solidFill>
                   <a:srgbClr val="3B3E46"/>
                 </a:solidFill>
                 <a:latin typeface="Arial"/>
               </a:rPr>
-              <a:t>on programme</a:t>
-            </a:r>
-          </a:p>
-        </p:txBody>
-      </p:sp>
-      <p:sp>
-        <p:nvSpPr>
-          <p:cNvPr id="14" name="Right Arrow 13"/>
+              <a:t>on le prépare</a:t>
+            </a:r>
+          </a:p>
+        </p:txBody>
+      </p:sp>
+      <p:sp>
+        <p:nvSpPr>
+          <p:cNvPr id="10" name="Right Arrow 9"/>
           <p:cNvSpPr/>
           <p:nvPr/>
         </p:nvSpPr>
         <p:spPr>
           <a:xfrm>
-            <a:off x="5994400" y="3048000"/>
-            <a:ext cx="203200" cy="254000"/>
+            <a:off x="4066540" y="3073400"/>
+            <a:ext cx="279400" cy="254000"/>
           </a:xfrm>
           <a:prstGeom prst="rightArrow">
             <a:avLst/>
@@ -11982,14 +11857,14 @@
       </p:sp>
       <p:sp>
         <p:nvSpPr>
-          <p:cNvPr id="15" name="Rectangle 14"/>
+          <p:cNvPr id="11" name="Rectangle 10"/>
           <p:cNvSpPr/>
           <p:nvPr/>
         </p:nvSpPr>
         <p:spPr>
           <a:xfrm>
-            <a:off x="6248400" y="2159000"/>
-            <a:ext cx="1574800" cy="2032000"/>
+            <a:off x="4389120" y="2184400"/>
+            <a:ext cx="1524000" cy="2032000"/>
           </a:xfrm>
           <a:prstGeom prst="rect">
             <a:avLst/>
@@ -12028,13 +11903,13 @@
       </p:sp>
       <p:sp>
         <p:nvSpPr>
-          <p:cNvPr id="16" name="TextBox 15"/>
+          <p:cNvPr id="12" name="TextBox 11"/>
           <p:cNvSpPr txBox="1"/>
           <p:nvPr/>
         </p:nvSpPr>
         <p:spPr>
           <a:xfrm>
-            <a:off x="6400800" y="2311400"/>
+            <a:off x="4516120" y="2336800"/>
             <a:ext cx="1270000" cy="304800"/>
           </a:xfrm>
           <a:prstGeom prst="rect">
@@ -12063,21 +11938,21 @@
                 </a:solidFill>
                 <a:latin typeface="Arial"/>
               </a:rPr>
-              <a:t>4</a:t>
-            </a:r>
-          </a:p>
-        </p:txBody>
-      </p:sp>
-      <p:sp>
-        <p:nvSpPr>
-          <p:cNvPr id="17" name="TextBox 16"/>
+              <a:t>3</a:t>
+            </a:r>
+          </a:p>
+        </p:txBody>
+      </p:sp>
+      <p:sp>
+        <p:nvSpPr>
+          <p:cNvPr id="13" name="TextBox 12"/>
           <p:cNvSpPr txBox="1"/>
           <p:nvPr/>
         </p:nvSpPr>
         <p:spPr>
           <a:xfrm>
-            <a:off x="6400800" y="2717800"/>
-            <a:ext cx="1270000" cy="1397000"/>
+            <a:off x="4516120" y="2743200"/>
+            <a:ext cx="1320800" cy="1397000"/>
           </a:xfrm>
           <a:prstGeom prst="rect">
             <a:avLst/>
@@ -12105,7 +11980,7 @@
                 </a:solidFill>
                 <a:latin typeface="Arial"/>
               </a:rPr>
-              <a:t>À l'heure</a:t>
+              <a:t>Animation</a:t>
             </a:r>
           </a:p>
           <a:p>
@@ -12118,27 +11993,27 @@
               </a:spcAft>
             </a:pPr>
             <a:r>
-              <a:rPr sz="1600" b="0">
+              <a:rPr sz="1800" b="0">
                 <a:solidFill>
                   <a:srgbClr val="3B3E46"/>
                 </a:solidFill>
                 <a:latin typeface="Arial"/>
               </a:rPr>
-              <a:t>publication automatique</a:t>
-            </a:r>
-          </a:p>
-        </p:txBody>
-      </p:sp>
-      <p:sp>
-        <p:nvSpPr>
-          <p:cNvPr id="18" name="Right Arrow 17"/>
+              <a:t>on programme</a:t>
+            </a:r>
+          </a:p>
+        </p:txBody>
+      </p:sp>
+      <p:sp>
+        <p:nvSpPr>
+          <p:cNvPr id="14" name="Right Arrow 13"/>
           <p:cNvSpPr/>
           <p:nvPr/>
         </p:nvSpPr>
         <p:spPr>
           <a:xfrm>
-            <a:off x="7874000" y="3048000"/>
-            <a:ext cx="203200" cy="254000"/>
+            <a:off x="5956300" y="3073400"/>
+            <a:ext cx="279400" cy="254000"/>
           </a:xfrm>
           <a:prstGeom prst="rightArrow">
             <a:avLst/>
@@ -12175,14 +12050,14 @@
       </p:sp>
       <p:sp>
         <p:nvSpPr>
-          <p:cNvPr id="19" name="Rectangle 18"/>
+          <p:cNvPr id="15" name="Rectangle 14"/>
           <p:cNvSpPr/>
           <p:nvPr/>
         </p:nvSpPr>
         <p:spPr>
           <a:xfrm>
-            <a:off x="8128000" y="2159000"/>
-            <a:ext cx="1574800" cy="2032000"/>
+            <a:off x="6278880" y="2184400"/>
+            <a:ext cx="1524000" cy="2032000"/>
           </a:xfrm>
           <a:prstGeom prst="rect">
             <a:avLst/>
@@ -12221,13 +12096,13 @@
       </p:sp>
       <p:sp>
         <p:nvSpPr>
-          <p:cNvPr id="20" name="TextBox 19"/>
+          <p:cNvPr id="16" name="TextBox 15"/>
           <p:cNvSpPr txBox="1"/>
           <p:nvPr/>
         </p:nvSpPr>
         <p:spPr>
           <a:xfrm>
-            <a:off x="8280400" y="2311400"/>
+            <a:off x="6405880" y="2336800"/>
             <a:ext cx="1270000" cy="304800"/>
           </a:xfrm>
           <a:prstGeom prst="rect">
@@ -12256,21 +12131,21 @@
                 </a:solidFill>
                 <a:latin typeface="Arial"/>
               </a:rPr>
-              <a:t>5</a:t>
-            </a:r>
-          </a:p>
-        </p:txBody>
-      </p:sp>
-      <p:sp>
-        <p:nvSpPr>
-          <p:cNvPr id="21" name="TextBox 20"/>
+              <a:t>4</a:t>
+            </a:r>
+          </a:p>
+        </p:txBody>
+      </p:sp>
+      <p:sp>
+        <p:nvSpPr>
+          <p:cNvPr id="17" name="TextBox 16"/>
           <p:cNvSpPr txBox="1"/>
           <p:nvPr/>
         </p:nvSpPr>
         <p:spPr>
           <a:xfrm>
-            <a:off x="8280400" y="2717800"/>
-            <a:ext cx="1270000" cy="1397000"/>
+            <a:off x="6405880" y="2743200"/>
+            <a:ext cx="1320800" cy="1397000"/>
           </a:xfrm>
           <a:prstGeom prst="rect">
             <a:avLst/>
@@ -12298,7 +12173,7 @@
                 </a:solidFill>
                 <a:latin typeface="Arial"/>
               </a:rPr>
-              <a:t>Joueurs</a:t>
+              <a:t>À l’heure</a:t>
             </a:r>
           </a:p>
           <a:p>
@@ -12311,27 +12186,27 @@
               </a:spcAft>
             </a:pPr>
             <a:r>
-              <a:rPr sz="1600" b="0">
+              <a:rPr sz="1800" b="0">
                 <a:solidFill>
                   <a:srgbClr val="3B3E46"/>
                 </a:solidFill>
                 <a:latin typeface="Arial"/>
               </a:rPr>
-              <a:t>réseau, presse, messagerie</a:t>
-            </a:r>
-          </a:p>
-        </p:txBody>
-      </p:sp>
-      <p:sp>
-        <p:nvSpPr>
-          <p:cNvPr id="22" name="Right Arrow 21"/>
+              <a:t>publication automatique</a:t>
+            </a:r>
+          </a:p>
+        </p:txBody>
+      </p:sp>
+      <p:sp>
+        <p:nvSpPr>
+          <p:cNvPr id="18" name="Right Arrow 17"/>
           <p:cNvSpPr/>
           <p:nvPr/>
         </p:nvSpPr>
         <p:spPr>
           <a:xfrm>
-            <a:off x="9753600" y="3048000"/>
-            <a:ext cx="203200" cy="254000"/>
+            <a:off x="7846060" y="3073400"/>
+            <a:ext cx="279400" cy="254000"/>
           </a:xfrm>
           <a:prstGeom prst="rightArrow">
             <a:avLst/>
@@ -12368,14 +12243,356 @@
       </p:sp>
       <p:sp>
         <p:nvSpPr>
+          <p:cNvPr id="19" name="Rectangle 18"/>
+          <p:cNvSpPr/>
+          <p:nvPr/>
+        </p:nvSpPr>
+        <p:spPr>
+          <a:xfrm>
+            <a:off x="8168640" y="2184400"/>
+            <a:ext cx="1524000" cy="2032000"/>
+          </a:xfrm>
+          <a:prstGeom prst="rect">
+            <a:avLst/>
+          </a:prstGeom>
+          <a:solidFill>
+            <a:srgbClr val="FFFFFF"/>
+          </a:solidFill>
+          <a:ln w="12700">
+            <a:solidFill>
+              <a:srgbClr val="C9C3B3"/>
+            </a:solidFill>
+          </a:ln>
+          <a:effectLst/>
+        </p:spPr>
+        <p:style>
+          <a:lnRef idx="1">
+            <a:schemeClr val="accent1"/>
+          </a:lnRef>
+          <a:fillRef idx="3">
+            <a:schemeClr val="accent1"/>
+          </a:fillRef>
+          <a:effectRef idx="2">
+            <a:schemeClr val="accent1"/>
+          </a:effectRef>
+          <a:fontRef idx="minor">
+            <a:schemeClr val="lt1"/>
+          </a:fontRef>
+        </p:style>
+        <p:txBody>
+          <a:bodyPr rtlCol="0" anchor="ctr"/>
+          <a:lstStyle/>
+          <a:p>
+            <a:pPr algn="ctr"/>
+          </a:p>
+        </p:txBody>
+      </p:sp>
+      <p:sp>
+        <p:nvSpPr>
+          <p:cNvPr id="20" name="TextBox 19"/>
+          <p:cNvSpPr txBox="1"/>
+          <p:nvPr/>
+        </p:nvSpPr>
+        <p:spPr>
+          <a:xfrm>
+            <a:off x="8295640" y="2336800"/>
+            <a:ext cx="1270000" cy="304800"/>
+          </a:xfrm>
+          <a:prstGeom prst="rect">
+            <a:avLst/>
+          </a:prstGeom>
+          <a:noFill/>
+        </p:spPr>
+        <p:txBody>
+          <a:bodyPr wrap="square" lIns="0" rIns="0" tIns="0" bIns="0" anchor="t">
+            <a:spAutoFit/>
+          </a:bodyPr>
+          <a:lstStyle/>
+          <a:p>
+            <a:pPr algn="l">
+              <a:lnSpc>
+                <a:spcPct val="110000"/>
+              </a:lnSpc>
+              <a:spcAft>
+                <a:spcPts val="0"/>
+              </a:spcAft>
+            </a:pPr>
+            <a:r>
+              <a:rPr sz="1800" b="1">
+                <a:solidFill>
+                  <a:srgbClr val="3B3E46"/>
+                </a:solidFill>
+                <a:latin typeface="Arial"/>
+              </a:rPr>
+              <a:t>5</a:t>
+            </a:r>
+          </a:p>
+        </p:txBody>
+      </p:sp>
+      <p:sp>
+        <p:nvSpPr>
+          <p:cNvPr id="21" name="TextBox 20"/>
+          <p:cNvSpPr txBox="1"/>
+          <p:nvPr/>
+        </p:nvSpPr>
+        <p:spPr>
+          <a:xfrm>
+            <a:off x="8295640" y="2743200"/>
+            <a:ext cx="1320800" cy="1397000"/>
+          </a:xfrm>
+          <a:prstGeom prst="rect">
+            <a:avLst/>
+          </a:prstGeom>
+          <a:noFill/>
+        </p:spPr>
+        <p:txBody>
+          <a:bodyPr wrap="square" lIns="0" rIns="0" tIns="0" bIns="0" anchor="t">
+            <a:spAutoFit/>
+          </a:bodyPr>
+          <a:lstStyle/>
+          <a:p>
+            <a:pPr algn="l">
+              <a:lnSpc>
+                <a:spcPct val="110000"/>
+              </a:lnSpc>
+              <a:spcAft>
+                <a:spcPts val="0"/>
+              </a:spcAft>
+            </a:pPr>
+            <a:r>
+              <a:rPr sz="2000" b="1">
+                <a:solidFill>
+                  <a:srgbClr val="14140F"/>
+                </a:solidFill>
+                <a:latin typeface="Arial"/>
+              </a:rPr>
+              <a:t>Joueurs</a:t>
+            </a:r>
+          </a:p>
+          <a:p>
+            <a:pPr algn="l">
+              <a:lnSpc>
+                <a:spcPct val="110000"/>
+              </a:lnSpc>
+              <a:spcAft>
+                <a:spcPts val="0"/>
+              </a:spcAft>
+            </a:pPr>
+            <a:r>
+              <a:rPr sz="1800" b="0">
+                <a:solidFill>
+                  <a:srgbClr val="3B3E46"/>
+                </a:solidFill>
+                <a:latin typeface="Arial"/>
+              </a:rPr>
+              <a:t>réseau, presse, messagerie</a:t>
+            </a:r>
+          </a:p>
+        </p:txBody>
+      </p:sp>
+      <p:sp>
+        <p:nvSpPr>
+          <p:cNvPr id="22" name="Right Arrow 21"/>
+          <p:cNvSpPr/>
+          <p:nvPr/>
+        </p:nvSpPr>
+        <p:spPr>
+          <a:xfrm>
+            <a:off x="9735820" y="3073400"/>
+            <a:ext cx="279400" cy="254000"/>
+          </a:xfrm>
+          <a:prstGeom prst="rightArrow">
+            <a:avLst/>
+          </a:prstGeom>
+          <a:solidFill>
+            <a:srgbClr val="3B3E46"/>
+          </a:solidFill>
+          <a:ln>
+            <a:noFill/>
+          </a:ln>
+          <a:effectLst/>
+        </p:spPr>
+        <p:style>
+          <a:lnRef idx="1">
+            <a:schemeClr val="accent1"/>
+          </a:lnRef>
+          <a:fillRef idx="3">
+            <a:schemeClr val="accent1"/>
+          </a:fillRef>
+          <a:effectRef idx="2">
+            <a:schemeClr val="accent1"/>
+          </a:effectRef>
+          <a:fontRef idx="minor">
+            <a:schemeClr val="lt1"/>
+          </a:fontRef>
+        </p:style>
+        <p:txBody>
+          <a:bodyPr rtlCol="0" anchor="ctr"/>
+          <a:lstStyle/>
+          <a:p>
+            <a:pPr algn="ctr"/>
+          </a:p>
+        </p:txBody>
+      </p:sp>
+      <p:sp>
+        <p:nvSpPr>
           <p:cNvPr id="23" name="Rectangle 22"/>
           <p:cNvSpPr/>
           <p:nvPr/>
         </p:nvSpPr>
         <p:spPr>
           <a:xfrm>
-            <a:off x="10007600" y="2159000"/>
-            <a:ext cx="1574800" cy="2032000"/>
+            <a:off x="10058400" y="2184400"/>
+            <a:ext cx="1524000" cy="2032000"/>
+          </a:xfrm>
+          <a:prstGeom prst="rect">
+            <a:avLst/>
+          </a:prstGeom>
+          <a:solidFill>
+            <a:srgbClr val="FFFFFF"/>
+          </a:solidFill>
+          <a:ln w="12700">
+            <a:solidFill>
+              <a:srgbClr val="C9C3B3"/>
+            </a:solidFill>
+          </a:ln>
+          <a:effectLst/>
+        </p:spPr>
+        <p:style>
+          <a:lnRef idx="1">
+            <a:schemeClr val="accent1"/>
+          </a:lnRef>
+          <a:fillRef idx="3">
+            <a:schemeClr val="accent1"/>
+          </a:fillRef>
+          <a:effectRef idx="2">
+            <a:schemeClr val="accent1"/>
+          </a:effectRef>
+          <a:fontRef idx="minor">
+            <a:schemeClr val="lt1"/>
+          </a:fontRef>
+        </p:style>
+        <p:txBody>
+          <a:bodyPr rtlCol="0" anchor="ctr"/>
+          <a:lstStyle/>
+          <a:p>
+            <a:pPr algn="ctr"/>
+          </a:p>
+        </p:txBody>
+      </p:sp>
+      <p:sp>
+        <p:nvSpPr>
+          <p:cNvPr id="24" name="TextBox 23"/>
+          <p:cNvSpPr txBox="1"/>
+          <p:nvPr/>
+        </p:nvSpPr>
+        <p:spPr>
+          <a:xfrm>
+            <a:off x="10185400" y="2336800"/>
+            <a:ext cx="1270000" cy="304800"/>
+          </a:xfrm>
+          <a:prstGeom prst="rect">
+            <a:avLst/>
+          </a:prstGeom>
+          <a:noFill/>
+        </p:spPr>
+        <p:txBody>
+          <a:bodyPr wrap="square" lIns="0" rIns="0" tIns="0" bIns="0" anchor="t">
+            <a:spAutoFit/>
+          </a:bodyPr>
+          <a:lstStyle/>
+          <a:p>
+            <a:pPr algn="l">
+              <a:lnSpc>
+                <a:spcPct val="110000"/>
+              </a:lnSpc>
+              <a:spcAft>
+                <a:spcPts val="0"/>
+              </a:spcAft>
+            </a:pPr>
+            <a:r>
+              <a:rPr sz="1800" b="1">
+                <a:solidFill>
+                  <a:srgbClr val="3B3E46"/>
+                </a:solidFill>
+                <a:latin typeface="Arial"/>
+              </a:rPr>
+              <a:t>6</a:t>
+            </a:r>
+          </a:p>
+        </p:txBody>
+      </p:sp>
+      <p:sp>
+        <p:nvSpPr>
+          <p:cNvPr id="25" name="TextBox 24"/>
+          <p:cNvSpPr txBox="1"/>
+          <p:nvPr/>
+        </p:nvSpPr>
+        <p:spPr>
+          <a:xfrm>
+            <a:off x="10185400" y="2743200"/>
+            <a:ext cx="1320800" cy="1397000"/>
+          </a:xfrm>
+          <a:prstGeom prst="rect">
+            <a:avLst/>
+          </a:prstGeom>
+          <a:noFill/>
+        </p:spPr>
+        <p:txBody>
+          <a:bodyPr wrap="square" lIns="0" rIns="0" tIns="0" bIns="0" anchor="t">
+            <a:spAutoFit/>
+          </a:bodyPr>
+          <a:lstStyle/>
+          <a:p>
+            <a:pPr algn="l">
+              <a:lnSpc>
+                <a:spcPct val="110000"/>
+              </a:lnSpc>
+              <a:spcAft>
+                <a:spcPts val="0"/>
+              </a:spcAft>
+            </a:pPr>
+            <a:r>
+              <a:rPr sz="2000" b="1">
+                <a:solidFill>
+                  <a:srgbClr val="14140F"/>
+                </a:solidFill>
+                <a:latin typeface="Arial"/>
+              </a:rPr>
+              <a:t>COCKPIT</a:t>
+            </a:r>
+          </a:p>
+          <a:p>
+            <a:pPr algn="l">
+              <a:lnSpc>
+                <a:spcPct val="110000"/>
+              </a:lnSpc>
+              <a:spcAft>
+                <a:spcPts val="0"/>
+              </a:spcAft>
+            </a:pPr>
+            <a:r>
+              <a:rPr sz="1800" b="0">
+                <a:solidFill>
+                  <a:srgbClr val="3B3E46"/>
+                </a:solidFill>
+                <a:latin typeface="Arial"/>
+              </a:rPr>
+              <a:t>on mesure</a:t>
+            </a:r>
+          </a:p>
+        </p:txBody>
+      </p:sp>
+      <p:sp>
+        <p:nvSpPr>
+          <p:cNvPr id="26" name="Rectangle 25"/>
+          <p:cNvSpPr/>
+          <p:nvPr/>
+        </p:nvSpPr>
+        <p:spPr>
+          <a:xfrm>
+            <a:off x="609600" y="4749800"/>
+            <a:ext cx="10972800" cy="660400"/>
           </a:xfrm>
           <a:prstGeom prst="rect">
             <a:avLst/>
@@ -12412,14 +12629,56 @@
       </p:sp>
       <p:sp>
         <p:nvSpPr>
-          <p:cNvPr id="24" name="TextBox 23"/>
+          <p:cNvPr id="27" name="TextBox 26"/>
           <p:cNvSpPr txBox="1"/>
           <p:nvPr/>
         </p:nvSpPr>
         <p:spPr>
           <a:xfrm>
-            <a:off x="10160000" y="2311400"/>
-            <a:ext cx="1270000" cy="304800"/>
+            <a:off x="863600" y="4749800"/>
+            <a:ext cx="10541000" cy="660400"/>
+          </a:xfrm>
+          <a:prstGeom prst="rect">
+            <a:avLst/>
+          </a:prstGeom>
+          <a:noFill/>
+        </p:spPr>
+        <p:txBody>
+          <a:bodyPr wrap="square" lIns="0" rIns="0" tIns="0" bIns="0" anchor="ctr">
+            <a:spAutoFit/>
+          </a:bodyPr>
+          <a:lstStyle/>
+          <a:p>
+            <a:pPr algn="l">
+              <a:lnSpc>
+                <a:spcPct val="110000"/>
+              </a:lnSpc>
+              <a:spcAft>
+                <a:spcPts val="0"/>
+              </a:spcAft>
+            </a:pPr>
+            <a:r>
+              <a:rPr sz="2000" b="0">
+                <a:solidFill>
+                  <a:srgbClr val="EDE3C8"/>
+                </a:solidFill>
+                <a:latin typeface="Arial"/>
+              </a:rPr>
+              <a:t>À chaque étape, les mêmes personnages, venus de l’EHO</a:t>
+            </a:r>
+          </a:p>
+        </p:txBody>
+      </p:sp>
+      <p:sp>
+        <p:nvSpPr>
+          <p:cNvPr id="28" name="TextBox 27"/>
+          <p:cNvSpPr txBox="1"/>
+          <p:nvPr/>
+        </p:nvSpPr>
+        <p:spPr>
+          <a:xfrm>
+            <a:off x="609600" y="6413500"/>
+            <a:ext cx="7620000" cy="203200"/>
           </a:xfrm>
           <a:prstGeom prst="rect">
             <a:avLst/>
@@ -12441,197 +12700,6 @@
               </a:spcAft>
             </a:pPr>
             <a:r>
-              <a:rPr sz="1800" b="1">
-                <a:solidFill>
-                  <a:srgbClr val="C3C8D8"/>
-                </a:solidFill>
-                <a:latin typeface="Arial"/>
-              </a:rPr>
-              <a:t>6</a:t>
-            </a:r>
-          </a:p>
-        </p:txBody>
-      </p:sp>
-      <p:sp>
-        <p:nvSpPr>
-          <p:cNvPr id="25" name="TextBox 24"/>
-          <p:cNvSpPr txBox="1"/>
-          <p:nvPr/>
-        </p:nvSpPr>
-        <p:spPr>
-          <a:xfrm>
-            <a:off x="10160000" y="2717800"/>
-            <a:ext cx="1270000" cy="1397000"/>
-          </a:xfrm>
-          <a:prstGeom prst="rect">
-            <a:avLst/>
-          </a:prstGeom>
-          <a:noFill/>
-        </p:spPr>
-        <p:txBody>
-          <a:bodyPr wrap="square" lIns="0" rIns="0" tIns="0" bIns="0" anchor="t">
-            <a:spAutoFit/>
-          </a:bodyPr>
-          <a:lstStyle/>
-          <a:p>
-            <a:pPr algn="l">
-              <a:lnSpc>
-                <a:spcPct val="110000"/>
-              </a:lnSpc>
-              <a:spcAft>
-                <a:spcPts val="0"/>
-              </a:spcAft>
-            </a:pPr>
-            <a:r>
-              <a:rPr sz="2000" b="1">
-                <a:solidFill>
-                  <a:srgbClr val="EDE3C8"/>
-                </a:solidFill>
-                <a:latin typeface="Arial"/>
-              </a:rPr>
-              <a:t>COCKPIT</a:t>
-            </a:r>
-          </a:p>
-          <a:p>
-            <a:pPr algn="l">
-              <a:lnSpc>
-                <a:spcPct val="110000"/>
-              </a:lnSpc>
-              <a:spcAft>
-                <a:spcPts val="0"/>
-              </a:spcAft>
-            </a:pPr>
-            <a:r>
-              <a:rPr sz="1600" b="0">
-                <a:solidFill>
-                  <a:srgbClr val="C3C8D8"/>
-                </a:solidFill>
-                <a:latin typeface="Arial"/>
-              </a:rPr>
-              <a:t>on mesure</a:t>
-            </a:r>
-          </a:p>
-        </p:txBody>
-      </p:sp>
-      <p:sp>
-        <p:nvSpPr>
-          <p:cNvPr id="26" name="Rectangle 25"/>
-          <p:cNvSpPr/>
-          <p:nvPr/>
-        </p:nvSpPr>
-        <p:spPr>
-          <a:xfrm>
-            <a:off x="609600" y="4724400"/>
-            <a:ext cx="10972800" cy="660400"/>
-          </a:xfrm>
-          <a:prstGeom prst="rect">
-            <a:avLst/>
-          </a:prstGeom>
-          <a:solidFill>
-            <a:srgbClr val="F3F0E7"/>
-          </a:solidFill>
-          <a:ln w="12700">
-            <a:solidFill>
-              <a:srgbClr val="1C1E21"/>
-            </a:solidFill>
-          </a:ln>
-          <a:effectLst/>
-        </p:spPr>
-        <p:style>
-          <a:lnRef idx="1">
-            <a:schemeClr val="accent1"/>
-          </a:lnRef>
-          <a:fillRef idx="3">
-            <a:schemeClr val="accent1"/>
-          </a:fillRef>
-          <a:effectRef idx="2">
-            <a:schemeClr val="accent1"/>
-          </a:effectRef>
-          <a:fontRef idx="minor">
-            <a:schemeClr val="lt1"/>
-          </a:fontRef>
-        </p:style>
-        <p:txBody>
-          <a:bodyPr rtlCol="0" anchor="ctr"/>
-          <a:lstStyle/>
-          <a:p>
-            <a:pPr algn="ctr"/>
-          </a:p>
-        </p:txBody>
-      </p:sp>
-      <p:sp>
-        <p:nvSpPr>
-          <p:cNvPr id="27" name="TextBox 26"/>
-          <p:cNvSpPr txBox="1"/>
-          <p:nvPr/>
-        </p:nvSpPr>
-        <p:spPr>
-          <a:xfrm>
-            <a:off x="863600" y="4724400"/>
-            <a:ext cx="10541000" cy="660400"/>
-          </a:xfrm>
-          <a:prstGeom prst="rect">
-            <a:avLst/>
-          </a:prstGeom>
-          <a:noFill/>
-        </p:spPr>
-        <p:txBody>
-          <a:bodyPr wrap="square" lIns="0" rIns="0" tIns="0" bIns="0" anchor="ctr">
-            <a:spAutoFit/>
-          </a:bodyPr>
-          <a:lstStyle/>
-          <a:p>
-            <a:pPr algn="l">
-              <a:lnSpc>
-                <a:spcPct val="110000"/>
-              </a:lnSpc>
-              <a:spcAft>
-                <a:spcPts val="0"/>
-              </a:spcAft>
-            </a:pPr>
-            <a:r>
-              <a:rPr sz="2000" b="0">
-                <a:solidFill>
-                  <a:srgbClr val="1C1E21"/>
-                </a:solidFill>
-                <a:latin typeface="Arial"/>
-              </a:rPr>
-              <a:t>À chaque étape, les mêmes personnages, venus de l'EHO</a:t>
-            </a:r>
-          </a:p>
-        </p:txBody>
-      </p:sp>
-      <p:sp>
-        <p:nvSpPr>
-          <p:cNvPr id="28" name="TextBox 27"/>
-          <p:cNvSpPr txBox="1"/>
-          <p:nvPr/>
-        </p:nvSpPr>
-        <p:spPr>
-          <a:xfrm>
-            <a:off x="609600" y="6477000"/>
-            <a:ext cx="7620000" cy="203200"/>
-          </a:xfrm>
-          <a:prstGeom prst="rect">
-            <a:avLst/>
-          </a:prstGeom>
-          <a:noFill/>
-        </p:spPr>
-        <p:txBody>
-          <a:bodyPr wrap="square" lIns="0" rIns="0" tIns="0" bIns="0" anchor="t">
-            <a:spAutoFit/>
-          </a:bodyPr>
-          <a:lstStyle/>
-          <a:p>
-            <a:pPr algn="l">
-              <a:lnSpc>
-                <a:spcPct val="110000"/>
-              </a:lnSpc>
-              <a:spcAft>
-                <a:spcPts val="0"/>
-              </a:spcAft>
-            </a:pPr>
-            <a:r>
               <a:rPr sz="1200" b="0">
                 <a:solidFill>
                   <a:srgbClr val="5B5F69"/>
@@ -12651,7 +12719,7 @@
         </p:nvSpPr>
         <p:spPr>
           <a:xfrm>
-            <a:off x="10312400" y="6477000"/>
+            <a:off x="10312400" y="6413500"/>
             <a:ext cx="1270000" cy="203200"/>
           </a:xfrm>
           <a:prstGeom prst="rect">
@@ -12748,7 +12816,26 @@
                 </a:solidFill>
                 <a:latin typeface="Arial"/>
               </a:rPr>
-              <a:t>Nouveauté DELATTRE 26 : un espace informationnel qui réagit</a:t>
+              <a:t>Nouveauté DELATTRE 26 :</a:t>
+            </a:r>
+          </a:p>
+          <a:p>
+            <a:pPr algn="l">
+              <a:lnSpc>
+                <a:spcPct val="105000"/>
+              </a:lnSpc>
+              <a:spcAft>
+                <a:spcPts val="0"/>
+              </a:spcAft>
+            </a:pPr>
+            <a:r>
+              <a:rPr sz="3200" b="1">
+                <a:solidFill>
+                  <a:srgbClr val="EDEEF2"/>
+                </a:solidFill>
+                <a:latin typeface="Arial"/>
+              </a:rPr>
+              <a:t>un espace informationnel qui réagit</a:t>
             </a:r>
           </a:p>
         </p:txBody>
@@ -12761,7 +12848,7 @@
         </p:nvSpPr>
         <p:spPr>
           <a:xfrm>
-            <a:off x="609600" y="1905000"/>
+            <a:off x="609600" y="2209800"/>
             <a:ext cx="5080000" cy="1905000"/>
           </a:xfrm>
           <a:prstGeom prst="rect">
@@ -12803,7 +12890,7 @@
         </p:nvSpPr>
         <p:spPr>
           <a:xfrm>
-            <a:off x="609600" y="3810000"/>
+            <a:off x="609600" y="4114800"/>
             <a:ext cx="5080000" cy="889000"/>
           </a:xfrm>
           <a:prstGeom prst="rect">
@@ -12851,7 +12938,7 @@
                 </a:solidFill>
                 <a:latin typeface="Arial"/>
               </a:rPr>
-              <a:t>joués par personne</a:t>
+              <a:t>sans joueur humain derrière</a:t>
             </a:r>
           </a:p>
         </p:txBody>
@@ -12864,7 +12951,7 @@
         </p:nvSpPr>
         <p:spPr>
           <a:xfrm>
-            <a:off x="6096000" y="2032000"/>
+            <a:off x="6096000" y="2336800"/>
             <a:ext cx="5486400" cy="304800"/>
           </a:xfrm>
           <a:prstGeom prst="rect">
@@ -12893,7 +12980,7 @@
                 </a:solidFill>
                 <a:latin typeface="Arial"/>
               </a:rPr>
-              <a:t>100 citoyens de l'Arnland</a:t>
+              <a:t>100 citoyens de l’Arnland</a:t>
             </a:r>
           </a:p>
         </p:txBody>
@@ -12906,7 +12993,7 @@
         </p:nvSpPr>
         <p:spPr>
           <a:xfrm>
-            <a:off x="6096000" y="2489200"/>
+            <a:off x="6096000" y="2794000"/>
             <a:ext cx="797560" cy="609600"/>
           </a:xfrm>
           <a:prstGeom prst="rect">
@@ -12950,8 +13037,8 @@
         </p:nvSpPr>
         <p:spPr>
           <a:xfrm>
-            <a:off x="6096000" y="3200400"/>
-            <a:ext cx="822960" cy="635000"/>
+            <a:off x="6096000" y="3505200"/>
+            <a:ext cx="1778000" cy="635000"/>
           </a:xfrm>
           <a:prstGeom prst="rect">
             <a:avLst/>
@@ -12964,7 +13051,7 @@
           </a:bodyPr>
           <a:lstStyle/>
           <a:p>
-            <a:pPr algn="ctr">
+            <a:pPr algn="l">
               <a:lnSpc>
                 <a:spcPct val="110000"/>
               </a:lnSpc>
@@ -12983,18 +13070,18 @@
             </a:r>
           </a:p>
           <a:p>
-            <a:pPr algn="ctr">
-              <a:lnSpc>
-                <a:spcPct val="110000"/>
-              </a:lnSpc>
-              <a:spcAft>
-                <a:spcPts val="0"/>
-              </a:spcAft>
-            </a:pPr>
-            <a:r>
-              <a:rPr sz="1600" b="0">
-                <a:solidFill>
-                  <a:srgbClr val="9AA0B4"/>
+            <a:pPr algn="l">
+              <a:lnSpc>
+                <a:spcPct val="110000"/>
+              </a:lnSpc>
+              <a:spcAft>
+                <a:spcPts val="0"/>
+              </a:spcAft>
+            </a:pPr>
+            <a:r>
+              <a:rPr sz="1800" b="0">
+                <a:solidFill>
+                  <a:srgbClr val="C3C8D8"/>
                 </a:solidFill>
                 <a:latin typeface="Arial"/>
               </a:rPr>
@@ -13011,7 +13098,7 @@
         </p:nvSpPr>
         <p:spPr>
           <a:xfrm>
-            <a:off x="6918959" y="2489200"/>
+            <a:off x="6918959" y="2794000"/>
             <a:ext cx="3815079" cy="609600"/>
           </a:xfrm>
           <a:prstGeom prst="rect">
@@ -13055,7 +13142,7 @@
         </p:nvSpPr>
         <p:spPr>
           <a:xfrm>
-            <a:off x="6918959" y="3200400"/>
+            <a:off x="6918959" y="3505200"/>
             <a:ext cx="3840479" cy="635000"/>
           </a:xfrm>
           <a:prstGeom prst="rect">
@@ -13097,9 +13184,9 @@
               </a:spcAft>
             </a:pPr>
             <a:r>
-              <a:rPr sz="1600" b="0">
-                <a:solidFill>
-                  <a:srgbClr val="9AA0B4"/>
+              <a:rPr sz="1800" b="0">
+                <a:solidFill>
+                  <a:srgbClr val="C3C8D8"/>
                 </a:solidFill>
                 <a:latin typeface="Arial"/>
               </a:rPr>
@@ -13116,7 +13203,7 @@
         </p:nvSpPr>
         <p:spPr>
           <a:xfrm>
-            <a:off x="10759440" y="2489200"/>
+            <a:off x="10759440" y="2794000"/>
             <a:ext cx="797560" cy="609600"/>
           </a:xfrm>
           <a:prstGeom prst="rect">
@@ -13160,8 +13247,8 @@
         </p:nvSpPr>
         <p:spPr>
           <a:xfrm>
-            <a:off x="10759440" y="3200400"/>
-            <a:ext cx="822960" cy="635000"/>
+            <a:off x="9804400" y="3505200"/>
+            <a:ext cx="1778000" cy="635000"/>
           </a:xfrm>
           <a:prstGeom prst="rect">
             <a:avLst/>
@@ -13174,7 +13261,7 @@
           </a:bodyPr>
           <a:lstStyle/>
           <a:p>
-            <a:pPr algn="ctr">
+            <a:pPr algn="r">
               <a:lnSpc>
                 <a:spcPct val="110000"/>
               </a:lnSpc>
@@ -13193,18 +13280,18 @@
             </a:r>
           </a:p>
           <a:p>
-            <a:pPr algn="ctr">
-              <a:lnSpc>
-                <a:spcPct val="110000"/>
-              </a:lnSpc>
-              <a:spcAft>
-                <a:spcPts val="0"/>
-              </a:spcAft>
-            </a:pPr>
-            <a:r>
-              <a:rPr sz="1600" b="0">
-                <a:solidFill>
-                  <a:srgbClr val="9AA0B4"/>
+            <a:pPr algn="r">
+              <a:lnSpc>
+                <a:spcPct val="110000"/>
+              </a:lnSpc>
+              <a:spcAft>
+                <a:spcPts val="0"/>
+              </a:spcAft>
+            </a:pPr>
+            <a:r>
+              <a:rPr sz="1800" b="0">
+                <a:solidFill>
+                  <a:srgbClr val="C3C8D8"/>
                 </a:solidFill>
                 <a:latin typeface="Arial"/>
               </a:rPr>
@@ -13221,7 +13308,7 @@
         </p:nvSpPr>
         <p:spPr>
           <a:xfrm>
-            <a:off x="6096000" y="4191000"/>
+            <a:off x="6096000" y="4495800"/>
             <a:ext cx="5486400" cy="762000"/>
           </a:xfrm>
           <a:prstGeom prst="rect">
@@ -13246,7 +13333,7 @@
             <a:r>
               <a:rPr sz="1800" b="0">
                 <a:solidFill>
-                  <a:srgbClr val="9AA0B4"/>
+                  <a:srgbClr val="C3C8D8"/>
                 </a:solidFill>
                 <a:latin typeface="Arial"/>
               </a:rPr>
@@ -13263,7 +13350,7 @@
         </p:nvSpPr>
         <p:spPr>
           <a:xfrm>
-            <a:off x="609600" y="6477000"/>
+            <a:off x="609600" y="6413500"/>
             <a:ext cx="7620000" cy="203200"/>
           </a:xfrm>
           <a:prstGeom prst="rect">
@@ -13305,7 +13392,7 @@
         </p:nvSpPr>
         <p:spPr>
           <a:xfrm>
-            <a:off x="10312400" y="6477000"/>
+            <a:off x="10312400" y="6413500"/>
             <a:ext cx="1270000" cy="203200"/>
           </a:xfrm>
           <a:prstGeom prst="rect">
@@ -13402,7 +13489,7 @@
                 </a:solidFill>
                 <a:latin typeface="Arial"/>
               </a:rPr>
-              <a:t>Le programme tient la psychologie ; l'IA ne fait que lire et formuler</a:t>
+              <a:t>Le programme tient la psychologie ; l’IA ne fait que lire et formuler</a:t>
             </a:r>
           </a:p>
         </p:txBody>
@@ -13416,7 +13503,7 @@
         <p:spPr>
           <a:xfrm>
             <a:off x="609600" y="2286000"/>
-            <a:ext cx="1905000" cy="1905000"/>
+            <a:ext cx="2159000" cy="1905000"/>
           </a:xfrm>
           <a:prstGeom prst="rect">
             <a:avLst/>
@@ -13462,7 +13549,7 @@
         <p:spPr>
           <a:xfrm>
             <a:off x="812800" y="2489200"/>
-            <a:ext cx="1498600" cy="1651000"/>
+            <a:ext cx="1752600" cy="1651000"/>
           </a:xfrm>
           <a:prstGeom prst="rect">
             <a:avLst/>
@@ -13490,7 +13577,7 @@
                 </a:solidFill>
                 <a:latin typeface="Arial"/>
               </a:rPr>
-              <a:t>L'IA lit</a:t>
+              <a:t>L’IA lit</a:t>
             </a:r>
           </a:p>
           <a:p>
@@ -13509,7 +13596,7 @@
                 </a:solidFill>
                 <a:latin typeface="Arial"/>
               </a:rPr>
-              <a:t>le fil d'actualité</a:t>
+              <a:t>le fil d’actualité</a:t>
             </a:r>
           </a:p>
         </p:txBody>
@@ -13522,8 +13609,8 @@
         </p:nvSpPr>
         <p:spPr>
           <a:xfrm>
-            <a:off x="3657600" y="2286000"/>
-            <a:ext cx="4191000" cy="1905000"/>
+            <a:off x="3327400" y="2286000"/>
+            <a:ext cx="3810000" cy="1905000"/>
           </a:xfrm>
           <a:prstGeom prst="rect">
             <a:avLst/>
@@ -13566,8 +13653,8 @@
         </p:nvSpPr>
         <p:spPr>
           <a:xfrm>
-            <a:off x="3860800" y="2489200"/>
-            <a:ext cx="3784600" cy="1651000"/>
+            <a:off x="3530600" y="2489200"/>
+            <a:ext cx="3403600" cy="1651000"/>
           </a:xfrm>
           <a:prstGeom prst="rect">
             <a:avLst/>
@@ -13614,7 +13701,26 @@
                 </a:solidFill>
                 <a:latin typeface="Arial"/>
               </a:rPr>
-              <a:t>humeur · mémoire · relations · opinions · qui réagit</a:t>
+              <a:t>humeur · mémoire · relations</a:t>
+            </a:r>
+          </a:p>
+          <a:p>
+            <a:pPr algn="l">
+              <a:lnSpc>
+                <a:spcPct val="110000"/>
+              </a:lnSpc>
+              <a:spcAft>
+                <a:spcPts val="0"/>
+              </a:spcAft>
+            </a:pPr>
+            <a:r>
+              <a:rPr sz="1800" b="0">
+                <a:solidFill>
+                  <a:srgbClr val="C3C8D8"/>
+                </a:solidFill>
+                <a:latin typeface="Arial"/>
+              </a:rPr>
+              <a:t>opinions · qui réagit</a:t>
             </a:r>
           </a:p>
         </p:txBody>
@@ -13627,8 +13733,8 @@
         </p:nvSpPr>
         <p:spPr>
           <a:xfrm>
-            <a:off x="8483600" y="2286000"/>
-            <a:ext cx="1905000" cy="1905000"/>
+            <a:off x="7696200" y="2286000"/>
+            <a:ext cx="2540000" cy="1905000"/>
           </a:xfrm>
           <a:prstGeom prst="rect">
             <a:avLst/>
@@ -13673,8 +13779,8 @@
         </p:nvSpPr>
         <p:spPr>
           <a:xfrm>
-            <a:off x="8686800" y="2489200"/>
-            <a:ext cx="1498600" cy="1651000"/>
+            <a:off x="7899400" y="2489200"/>
+            <a:ext cx="2133600" cy="1651000"/>
           </a:xfrm>
           <a:prstGeom prst="rect">
             <a:avLst/>
@@ -13702,7 +13808,7 @@
                 </a:solidFill>
                 <a:latin typeface="Arial"/>
               </a:rPr>
-              <a:t>L'IA formule</a:t>
+              <a:t>L’IA formule</a:t>
             </a:r>
           </a:p>
           <a:p>
@@ -13734,8 +13840,8 @@
         </p:nvSpPr>
         <p:spPr>
           <a:xfrm>
-            <a:off x="2616200" y="3111500"/>
-            <a:ext cx="939800" cy="279400"/>
+            <a:off x="2908300" y="3124200"/>
+            <a:ext cx="279400" cy="254000"/>
           </a:xfrm>
           <a:prstGeom prst="rightArrow">
             <a:avLst/>
@@ -13778,8 +13884,8 @@
         </p:nvSpPr>
         <p:spPr>
           <a:xfrm>
-            <a:off x="7950200" y="3111500"/>
-            <a:ext cx="431800" cy="279400"/>
+            <a:off x="7277100" y="3124200"/>
+            <a:ext cx="279400" cy="254000"/>
           </a:xfrm>
           <a:prstGeom prst="rightArrow">
             <a:avLst/>
@@ -13822,8 +13928,8 @@
         </p:nvSpPr>
         <p:spPr>
           <a:xfrm>
-            <a:off x="10566400" y="2286000"/>
-            <a:ext cx="76200" cy="1905000"/>
+            <a:off x="10439400" y="2286000"/>
+            <a:ext cx="76200" cy="2082800"/>
           </a:xfrm>
           <a:prstGeom prst="rect">
             <a:avLst/>
@@ -13866,8 +13972,8 @@
         </p:nvSpPr>
         <p:spPr>
           <a:xfrm>
-            <a:off x="10744200" y="2921000"/>
-            <a:ext cx="1016000" cy="635000"/>
+            <a:off x="10642600" y="2921000"/>
+            <a:ext cx="939800" cy="635000"/>
           </a:xfrm>
           <a:prstGeom prst="rect">
             <a:avLst/>
@@ -13908,8 +14014,8 @@
         </p:nvSpPr>
         <p:spPr>
           <a:xfrm>
-            <a:off x="8483600" y="4394200"/>
-            <a:ext cx="3098800" cy="762000"/>
+            <a:off x="7696200" y="4445000"/>
+            <a:ext cx="3886200" cy="762000"/>
           </a:xfrm>
           <a:prstGeom prst="rect">
             <a:avLst/>
@@ -13922,22 +14028,41 @@
           </a:bodyPr>
           <a:lstStyle/>
           <a:p>
-            <a:pPr algn="l">
-              <a:lnSpc>
-                <a:spcPct val="110000"/>
-              </a:lnSpc>
-              <a:spcAft>
-                <a:spcPts val="0"/>
-              </a:spcAft>
-            </a:pPr>
-            <a:r>
-              <a:rPr sz="1600" b="0">
+            <a:pPr algn="r">
+              <a:lnSpc>
+                <a:spcPct val="110000"/>
+              </a:lnSpc>
+              <a:spcAft>
+                <a:spcPts val="0"/>
+              </a:spcAft>
+            </a:pPr>
+            <a:r>
+              <a:rPr sz="1800" b="0">
                 <a:solidFill>
                   <a:srgbClr val="3B3E46"/>
                 </a:solidFill>
                 <a:latin typeface="Arial"/>
               </a:rPr>
-              <a:t>Garde-fous avant publication : relecture, interdits, plafonds, interrupteur</a:t>
+              <a:t>Garde-fous : relecture, interdits,</a:t>
+            </a:r>
+          </a:p>
+          <a:p>
+            <a:pPr algn="r">
+              <a:lnSpc>
+                <a:spcPct val="110000"/>
+              </a:lnSpc>
+              <a:spcAft>
+                <a:spcPts val="0"/>
+              </a:spcAft>
+            </a:pPr>
+            <a:r>
+              <a:rPr sz="1800" b="0">
+                <a:solidFill>
+                  <a:srgbClr val="3B3E46"/>
+                </a:solidFill>
+                <a:latin typeface="Arial"/>
+              </a:rPr>
+              <a:t>plafonds, interrupteur</a:t>
             </a:r>
           </a:p>
         </p:txBody>
@@ -13979,7 +14104,7 @@
                 </a:solidFill>
                 <a:latin typeface="Arial"/>
               </a:rPr>
-              <a:t>◐ En essai : rédacteur dédié et 36 nuances d'émotion</a:t>
+              <a:t>◐ En essai : rédacteur dédié et 36 nuances d’émotion</a:t>
             </a:r>
           </a:p>
         </p:txBody>
@@ -13992,7 +14117,7 @@
         </p:nvSpPr>
         <p:spPr>
           <a:xfrm>
-            <a:off x="609600" y="6477000"/>
+            <a:off x="609600" y="6413500"/>
             <a:ext cx="7620000" cy="203200"/>
           </a:xfrm>
           <a:prstGeom prst="rect">
@@ -14034,7 +14159,7 @@
         </p:nvSpPr>
         <p:spPr>
           <a:xfrm>
-            <a:off x="10312400" y="6477000"/>
+            <a:off x="10312400" y="6413500"/>
             <a:ext cx="1270000" cy="203200"/>
           </a:xfrm>
           <a:prstGeom prst="rect">
@@ -14131,7 +14256,7 @@
                 </a:solidFill>
                 <a:latin typeface="Arial"/>
               </a:rPr>
-              <a:t>Pour la première fois, on voit l'effet d'une action de joueur sur l'opinion</a:t>
+              <a:t>Pour la première fois, on voit l’effet d’une action de joueur sur l’opinion</a:t>
             </a:r>
           </a:p>
         </p:txBody>
@@ -14145,8 +14270,8 @@
           <p:nvPr/>
         </p:nvGraphicFramePr>
         <p:xfrm>
-          <a:off x="609600" y="1905000"/>
-          <a:ext cx="7112000" cy="3810000"/>
+          <a:off x="609600" y="2540000"/>
+          <a:ext cx="7112000" cy="3505200"/>
         </p:xfrm>
         <a:graphic>
           <a:graphicData uri="http://schemas.openxmlformats.org/drawingml/2006/chart">
@@ -14162,8 +14287,8 @@
         </p:nvSpPr>
         <p:spPr>
           <a:xfrm>
-            <a:off x="812800" y="1905000"/>
-            <a:ext cx="5334000" cy="254000"/>
+            <a:off x="609600" y="1905000"/>
+            <a:ext cx="7112000" cy="279400"/>
           </a:xfrm>
           <a:prstGeom prst="rect">
             <a:avLst/>
@@ -14185,9 +14310,51 @@
               </a:spcAft>
             </a:pPr>
             <a:r>
-              <a:rPr sz="1400" b="1">
-                <a:solidFill>
-                  <a:srgbClr val="5B5F69"/>
+              <a:rPr sz="1800" b="1">
+                <a:solidFill>
+                  <a:srgbClr val="14140F"/>
+                </a:solidFill>
+                <a:latin typeface="Arial"/>
+              </a:rPr>
+              <a:t>Opinion moyenne de la population IA</a:t>
+            </a:r>
+          </a:p>
+        </p:txBody>
+      </p:sp>
+      <p:sp>
+        <p:nvSpPr>
+          <p:cNvPr id="5" name="TextBox 4"/>
+          <p:cNvSpPr txBox="1"/>
+          <p:nvPr/>
+        </p:nvSpPr>
+        <p:spPr>
+          <a:xfrm>
+            <a:off x="609600" y="2209800"/>
+            <a:ext cx="7112000" cy="279400"/>
+          </a:xfrm>
+          <a:prstGeom prst="rect">
+            <a:avLst/>
+          </a:prstGeom>
+          <a:noFill/>
+        </p:spPr>
+        <p:txBody>
+          <a:bodyPr wrap="square" lIns="0" rIns="0" tIns="0" bIns="0" anchor="t">
+            <a:spAutoFit/>
+          </a:bodyPr>
+          <a:lstStyle/>
+          <a:p>
+            <a:pPr algn="l">
+              <a:lnSpc>
+                <a:spcPct val="110000"/>
+              </a:lnSpc>
+              <a:spcAft>
+                <a:spcPts val="0"/>
+              </a:spcAft>
+            </a:pPr>
+            <a:r>
+              <a:rPr sz="1800" b="1">
+                <a:solidFill>
+                  <a:srgbClr val="3B3E46"/>
                 </a:solidFill>
                 <a:latin typeface="Arial"/>
               </a:rPr>
@@ -14198,14 +14365,14 @@
       </p:sp>
       <p:sp>
         <p:nvSpPr>
-          <p:cNvPr id="5" name="Rectangle 4"/>
+          <p:cNvPr id="6" name="Rectangle 5"/>
           <p:cNvSpPr/>
           <p:nvPr/>
         </p:nvSpPr>
         <p:spPr>
           <a:xfrm>
-            <a:off x="3810000" y="3225800"/>
-            <a:ext cx="25400" cy="2032000"/>
+            <a:off x="3810000" y="2730500"/>
+            <a:ext cx="25400" cy="2832100"/>
           </a:xfrm>
           <a:prstGeom prst="rect">
             <a:avLst/>
@@ -14242,14 +14409,14 @@
       </p:sp>
       <p:sp>
         <p:nvSpPr>
-          <p:cNvPr id="6" name="TextBox 5"/>
+          <p:cNvPr id="7" name="TextBox 6"/>
           <p:cNvSpPr txBox="1"/>
           <p:nvPr/>
         </p:nvSpPr>
         <p:spPr>
           <a:xfrm>
-            <a:off x="3911600" y="4953000"/>
-            <a:ext cx="2286000" cy="508000"/>
+            <a:off x="3911600" y="4978400"/>
+            <a:ext cx="2540000" cy="508000"/>
           </a:xfrm>
           <a:prstGeom prst="rect">
             <a:avLst/>
@@ -14271,7 +14438,7 @@
               </a:spcAft>
             </a:pPr>
             <a:r>
-              <a:rPr sz="1600" b="0">
+              <a:rPr sz="1800" b="0">
                 <a:solidFill>
                   <a:srgbClr val="3B3E46"/>
                 </a:solidFill>
@@ -14284,14 +14451,14 @@
       </p:sp>
       <p:sp>
         <p:nvSpPr>
-          <p:cNvPr id="7" name="TextBox 6"/>
+          <p:cNvPr id="8" name="TextBox 7"/>
           <p:cNvSpPr txBox="1"/>
           <p:nvPr/>
         </p:nvSpPr>
         <p:spPr>
           <a:xfrm>
-            <a:off x="8128000" y="1905000"/>
-            <a:ext cx="3454400" cy="355600"/>
+            <a:off x="1422400" y="2717800"/>
+            <a:ext cx="1651000" cy="279400"/>
           </a:xfrm>
           <a:prstGeom prst="rect">
             <a:avLst/>
@@ -14313,6 +14480,90 @@
               </a:spcAft>
             </a:pPr>
             <a:r>
+              <a:rPr sz="1800" b="0">
+                <a:solidFill>
+                  <a:srgbClr val="3B3E46"/>
+                </a:solidFill>
+                <a:latin typeface="Arial"/>
+              </a:rPr>
+              <a:t>▲ soutient</a:t>
+            </a:r>
+          </a:p>
+        </p:txBody>
+      </p:sp>
+      <p:sp>
+        <p:nvSpPr>
+          <p:cNvPr id="9" name="TextBox 8"/>
+          <p:cNvSpPr txBox="1"/>
+          <p:nvPr/>
+        </p:nvSpPr>
+        <p:spPr>
+          <a:xfrm>
+            <a:off x="1422400" y="5207000"/>
+            <a:ext cx="1651000" cy="279400"/>
+          </a:xfrm>
+          <a:prstGeom prst="rect">
+            <a:avLst/>
+          </a:prstGeom>
+          <a:noFill/>
+        </p:spPr>
+        <p:txBody>
+          <a:bodyPr wrap="square" lIns="0" rIns="0" tIns="0" bIns="0" anchor="t">
+            <a:spAutoFit/>
+          </a:bodyPr>
+          <a:lstStyle/>
+          <a:p>
+            <a:pPr algn="l">
+              <a:lnSpc>
+                <a:spcPct val="110000"/>
+              </a:lnSpc>
+              <a:spcAft>
+                <a:spcPts val="0"/>
+              </a:spcAft>
+            </a:pPr>
+            <a:r>
+              <a:rPr sz="1800" b="0">
+                <a:solidFill>
+                  <a:srgbClr val="3B3E46"/>
+                </a:solidFill>
+                <a:latin typeface="Arial"/>
+              </a:rPr>
+              <a:t>▼ rejette</a:t>
+            </a:r>
+          </a:p>
+        </p:txBody>
+      </p:sp>
+      <p:sp>
+        <p:nvSpPr>
+          <p:cNvPr id="10" name="TextBox 9"/>
+          <p:cNvSpPr txBox="1"/>
+          <p:nvPr/>
+        </p:nvSpPr>
+        <p:spPr>
+          <a:xfrm>
+            <a:off x="8128000" y="1905000"/>
+            <a:ext cx="3454400" cy="355600"/>
+          </a:xfrm>
+          <a:prstGeom prst="rect">
+            <a:avLst/>
+          </a:prstGeom>
+          <a:noFill/>
+        </p:spPr>
+        <p:txBody>
+          <a:bodyPr wrap="square" lIns="0" rIns="0" tIns="0" bIns="0" anchor="t">
+            <a:spAutoFit/>
+          </a:bodyPr>
+          <a:lstStyle/>
+          <a:p>
+            <a:pPr algn="l">
+              <a:lnSpc>
+                <a:spcPct val="110000"/>
+              </a:lnSpc>
+              <a:spcAft>
+                <a:spcPts val="0"/>
+              </a:spcAft>
+            </a:pPr>
+            <a:r>
               <a:rPr sz="2000" b="1">
                 <a:solidFill>
                   <a:srgbClr val="14140F"/>
@@ -14326,7 +14577,7 @@
       </p:sp>
       <p:sp>
         <p:nvSpPr>
-          <p:cNvPr id="8" name="Rectangle 7"/>
+          <p:cNvPr id="11" name="Rectangle 10"/>
           <p:cNvSpPr/>
           <p:nvPr/>
         </p:nvSpPr>
@@ -14370,7 +14621,7 @@
       </p:sp>
       <p:sp>
         <p:nvSpPr>
-          <p:cNvPr id="9" name="TextBox 8"/>
+          <p:cNvPr id="12" name="TextBox 11"/>
           <p:cNvSpPr txBox="1"/>
           <p:nvPr/>
         </p:nvSpPr>
@@ -14405,20 +14656,20 @@
                 </a:solidFill>
                 <a:latin typeface="Arial"/>
               </a:rPr>
-              <a:t>l'activité par série de comptes</a:t>
-            </a:r>
-          </a:p>
-        </p:txBody>
-      </p:sp>
-      <p:sp>
-        <p:nvSpPr>
-          <p:cNvPr id="10" name="Rectangle 9"/>
+              <a:t>l’activité par série de comptes</a:t>
+            </a:r>
+          </a:p>
+        </p:txBody>
+      </p:sp>
+      <p:sp>
+        <p:nvSpPr>
+          <p:cNvPr id="13" name="Rectangle 12"/>
           <p:cNvSpPr/>
           <p:nvPr/>
         </p:nvSpPr>
         <p:spPr>
           <a:xfrm>
-            <a:off x="8128000" y="3327400"/>
+            <a:off x="8128000" y="3429000"/>
             <a:ext cx="127000" cy="127000"/>
           </a:xfrm>
           <a:prstGeom prst="rect">
@@ -14456,13 +14707,13 @@
       </p:sp>
       <p:sp>
         <p:nvSpPr>
-          <p:cNvPr id="11" name="TextBox 10"/>
+          <p:cNvPr id="14" name="TextBox 13"/>
           <p:cNvSpPr txBox="1"/>
           <p:nvPr/>
         </p:nvSpPr>
         <p:spPr>
           <a:xfrm>
-            <a:off x="8407400" y="3225800"/>
+            <a:off x="8407400" y="3327400"/>
             <a:ext cx="3175000" cy="711200"/>
           </a:xfrm>
           <a:prstGeom prst="rect">
@@ -14498,13 +14749,13 @@
       </p:sp>
       <p:sp>
         <p:nvSpPr>
-          <p:cNvPr id="12" name="Rectangle 11"/>
+          <p:cNvPr id="15" name="Rectangle 14"/>
           <p:cNvSpPr/>
           <p:nvPr/>
         </p:nvSpPr>
         <p:spPr>
           <a:xfrm>
-            <a:off x="8128000" y="4089400"/>
+            <a:off x="8128000" y="3987800"/>
             <a:ext cx="127000" cy="127000"/>
           </a:xfrm>
           <a:prstGeom prst="rect">
@@ -14542,13 +14793,13 @@
       </p:sp>
       <p:sp>
         <p:nvSpPr>
-          <p:cNvPr id="13" name="TextBox 12"/>
+          <p:cNvPr id="16" name="TextBox 15"/>
           <p:cNvSpPr txBox="1"/>
           <p:nvPr/>
         </p:nvSpPr>
         <p:spPr>
           <a:xfrm>
-            <a:off x="8407400" y="3987800"/>
+            <a:off x="8407400" y="3886200"/>
             <a:ext cx="3175000" cy="711200"/>
           </a:xfrm>
           <a:prstGeom prst="rect">
@@ -14577,20 +14828,20 @@
                 </a:solidFill>
                 <a:latin typeface="Arial"/>
               </a:rPr>
-              <a:t>l'opinion sur chaque axe</a:t>
-            </a:r>
-          </a:p>
-        </p:txBody>
-      </p:sp>
-      <p:sp>
-        <p:nvSpPr>
-          <p:cNvPr id="14" name="Rectangle 13"/>
+              <a:t>l’opinion sur chaque axe</a:t>
+            </a:r>
+          </a:p>
+        </p:txBody>
+      </p:sp>
+      <p:sp>
+        <p:nvSpPr>
+          <p:cNvPr id="17" name="Rectangle 16"/>
           <p:cNvSpPr/>
           <p:nvPr/>
         </p:nvSpPr>
         <p:spPr>
           <a:xfrm>
-            <a:off x="8128000" y="4851400"/>
+            <a:off x="8128000" y="4546600"/>
             <a:ext cx="127000" cy="127000"/>
           </a:xfrm>
           <a:prstGeom prst="rect">
@@ -14628,13 +14879,13 @@
       </p:sp>
       <p:sp>
         <p:nvSpPr>
-          <p:cNvPr id="15" name="TextBox 14"/>
+          <p:cNvPr id="18" name="TextBox 17"/>
           <p:cNvSpPr txBox="1"/>
           <p:nvPr/>
         </p:nvSpPr>
         <p:spPr>
           <a:xfrm>
-            <a:off x="8407400" y="4749800"/>
+            <a:off x="8407400" y="4445000"/>
             <a:ext cx="3175000" cy="711200"/>
           </a:xfrm>
           <a:prstGeom prst="rect">
@@ -14663,20 +14914,20 @@
                 </a:solidFill>
                 <a:latin typeface="Arial"/>
               </a:rPr>
-              <a:t>qui la fait bouger : joueurs, IA ou faits</a:t>
-            </a:r>
-          </a:p>
-        </p:txBody>
-      </p:sp>
-      <p:sp>
-        <p:nvSpPr>
-          <p:cNvPr id="16" name="TextBox 15"/>
+              <a:t>qui la fait bouger : joueurs, IA ou faits</a:t>
+            </a:r>
+          </a:p>
+        </p:txBody>
+      </p:sp>
+      <p:sp>
+        <p:nvSpPr>
+          <p:cNvPr id="19" name="TextBox 18"/>
           <p:cNvSpPr txBox="1"/>
           <p:nvPr/>
         </p:nvSpPr>
         <p:spPr>
           <a:xfrm>
-            <a:off x="609600" y="6477000"/>
+            <a:off x="609600" y="6413500"/>
             <a:ext cx="7620000" cy="203200"/>
           </a:xfrm>
           <a:prstGeom prst="rect">
@@ -14712,13 +14963,13 @@
       </p:sp>
       <p:sp>
         <p:nvSpPr>
-          <p:cNvPr id="17" name="TextBox 16"/>
+          <p:cNvPr id="20" name="TextBox 19"/>
           <p:cNvSpPr txBox="1"/>
           <p:nvPr/>
         </p:nvSpPr>
         <p:spPr>
           <a:xfrm>
-            <a:off x="10312400" y="6477000"/>
+            <a:off x="10312400" y="6413500"/>
             <a:ext cx="1270000" cy="203200"/>
           </a:xfrm>
           <a:prstGeom prst="rect">

</xml_diff>